<commit_message>
updated logos, exercises for scheduling, and overview
</commit_message>
<xml_diff>
--- a/slides/synchronization_part_1.pptx
+++ b/slides/synchronization_part_1.pptx
@@ -181,22 +181,6 @@
 
 <file path=ppt/changesInfos/changesInfo1.xml><?xml version="1.0" encoding="utf-8"?>
 <pc:chgInfo xmlns:a="http://schemas.openxmlformats.org/drawingml/2006/main" xmlns:r="http://schemas.openxmlformats.org/officeDocument/2006/relationships" xmlns:ac="http://schemas.microsoft.com/office/drawing/2013/main/command" xmlns:pc="http://schemas.microsoft.com/office/powerpoint/2013/main/command">
-  <pc:docChgLst>
-    <pc:chgData name="Vincenzo Massimiliano Gulisano" userId="887d7398-9e41-4331-abd4-9c23f064ea90" providerId="ADAL" clId="{6259EB42-2F4C-334B-A99B-A5E9EA13789A}"/>
-    <pc:docChg chg="undo custSel modSld">
-      <pc:chgData name="Vincenzo Massimiliano Gulisano" userId="887d7398-9e41-4331-abd4-9c23f064ea90" providerId="ADAL" clId="{6259EB42-2F4C-334B-A99B-A5E9EA13789A}" dt="2022-09-19T06:46:23.441" v="7" actId="20577"/>
-      <pc:docMkLst>
-        <pc:docMk/>
-      </pc:docMkLst>
-      <pc:sldChg chg="modSp mod">
-        <pc:chgData name="Vincenzo Massimiliano Gulisano" userId="887d7398-9e41-4331-abd4-9c23f064ea90" providerId="ADAL" clId="{6259EB42-2F4C-334B-A99B-A5E9EA13789A}" dt="2022-09-19T06:46:23.441" v="7" actId="20577"/>
-        <pc:sldMkLst>
-          <pc:docMk/>
-          <pc:sldMk cId="4168396551" sldId="300"/>
-        </pc:sldMkLst>
-      </pc:sldChg>
-    </pc:docChg>
-  </pc:docChgLst>
   <pc:docChgLst>
     <pc:chgData name="Vincenzo Massimiliano Gulisano" userId="887d7398-9e41-4331-abd4-9c23f064ea90" providerId="ADAL" clId="{8EA10870-6395-588A-9409-E8E4CA631CF7}"/>
     <pc:docChg chg="undo redo custSel addSld delSld modSld">
@@ -473,6 +457,22 @@
       </pc:sldChg>
     </pc:docChg>
   </pc:docChgLst>
+  <pc:docChgLst>
+    <pc:chgData name="Vincenzo Massimiliano Gulisano" userId="887d7398-9e41-4331-abd4-9c23f064ea90" providerId="ADAL" clId="{6259EB42-2F4C-334B-A99B-A5E9EA13789A}"/>
+    <pc:docChg chg="undo custSel modSld">
+      <pc:chgData name="Vincenzo Massimiliano Gulisano" userId="887d7398-9e41-4331-abd4-9c23f064ea90" providerId="ADAL" clId="{6259EB42-2F4C-334B-A99B-A5E9EA13789A}" dt="2022-09-19T06:46:23.441" v="7" actId="20577"/>
+      <pc:docMkLst>
+        <pc:docMk/>
+      </pc:docMkLst>
+      <pc:sldChg chg="modSp mod">
+        <pc:chgData name="Vincenzo Massimiliano Gulisano" userId="887d7398-9e41-4331-abd4-9c23f064ea90" providerId="ADAL" clId="{6259EB42-2F4C-334B-A99B-A5E9EA13789A}" dt="2022-09-19T06:46:23.441" v="7" actId="20577"/>
+        <pc:sldMkLst>
+          <pc:docMk/>
+          <pc:sldMk cId="4168396551" sldId="300"/>
+        </pc:sldMkLst>
+      </pc:sldChg>
+    </pc:docChg>
+  </pc:docChgLst>
 </pc:chgInfo>
 </file>
 
@@ -558,7 +558,7 @@
           <a:p>
             <a:fld id="{B9670FC7-431C-3445-825C-360F18AD9FB0}" type="datetimeFigureOut">
               <a:rPr lang="en-US" smtClean="0"/>
-              <a:t>10/2/25</a:t>
+              <a:t>7/14/26</a:t>
             </a:fld>
             <a:endParaRPr lang="en-US"/>
           </a:p>
@@ -7876,7 +7876,10 @@
           <a:bodyPr/>
           <a:lstStyle/>
           <a:p>
-            <a:endParaRPr lang="en-US"/>
+            <a:r>
+              <a:rPr lang="en-US"/>
+              <a:t>Vincenzo Gulisano</a:t>
+            </a:r>
           </a:p>
         </p:txBody>
       </p:sp>
@@ -8072,7 +8075,10 @@
           <a:bodyPr/>
           <a:lstStyle/>
           <a:p>
-            <a:endParaRPr lang="en-US"/>
+            <a:r>
+              <a:rPr lang="en-US"/>
+              <a:t>Vincenzo Gulisano</a:t>
+            </a:r>
           </a:p>
         </p:txBody>
       </p:sp>
@@ -8278,7 +8284,10 @@
           <a:bodyPr/>
           <a:lstStyle/>
           <a:p>
-            <a:endParaRPr lang="en-US"/>
+            <a:r>
+              <a:rPr lang="en-US"/>
+              <a:t>Vincenzo Gulisano</a:t>
+            </a:r>
           </a:p>
         </p:txBody>
       </p:sp>
@@ -8836,7 +8845,10 @@
           <a:bodyPr/>
           <a:lstStyle/>
           <a:p>
-            <a:endParaRPr lang="en-US"/>
+            <a:r>
+              <a:rPr lang="en-US"/>
+              <a:t>Vincenzo Gulisano</a:t>
+            </a:r>
           </a:p>
         </p:txBody>
       </p:sp>
@@ -9108,7 +9120,10 @@
           <a:bodyPr/>
           <a:lstStyle/>
           <a:p>
-            <a:endParaRPr lang="en-US"/>
+            <a:r>
+              <a:rPr lang="en-US"/>
+              <a:t>Vincenzo Gulisano</a:t>
+            </a:r>
           </a:p>
         </p:txBody>
       </p:sp>
@@ -9372,7 +9387,10 @@
           <a:bodyPr/>
           <a:lstStyle/>
           <a:p>
-            <a:endParaRPr lang="en-US"/>
+            <a:r>
+              <a:rPr lang="en-US"/>
+              <a:t>Vincenzo Gulisano</a:t>
+            </a:r>
           </a:p>
         </p:txBody>
       </p:sp>
@@ -9783,7 +9801,10 @@
           <a:bodyPr/>
           <a:lstStyle/>
           <a:p>
-            <a:endParaRPr lang="en-US"/>
+            <a:r>
+              <a:rPr lang="en-US"/>
+              <a:t>Vincenzo Gulisano</a:t>
+            </a:r>
           </a:p>
         </p:txBody>
       </p:sp>
@@ -9921,7 +9942,10 @@
           <a:bodyPr/>
           <a:lstStyle/>
           <a:p>
-            <a:endParaRPr lang="en-US"/>
+            <a:r>
+              <a:rPr lang="en-US"/>
+              <a:t>Vincenzo Gulisano</a:t>
+            </a:r>
           </a:p>
         </p:txBody>
       </p:sp>
@@ -10030,7 +10054,10 @@
           <a:bodyPr/>
           <a:lstStyle/>
           <a:p>
-            <a:endParaRPr lang="en-US"/>
+            <a:r>
+              <a:rPr lang="en-US"/>
+              <a:t>Vincenzo Gulisano</a:t>
+            </a:r>
           </a:p>
         </p:txBody>
       </p:sp>
@@ -10339,7 +10366,10 @@
           <a:bodyPr/>
           <a:lstStyle/>
           <a:p>
-            <a:endParaRPr lang="en-US"/>
+            <a:r>
+              <a:rPr lang="en-US"/>
+              <a:t>Vincenzo Gulisano</a:t>
+            </a:r>
           </a:p>
         </p:txBody>
       </p:sp>
@@ -10624,7 +10654,10 @@
           <a:bodyPr/>
           <a:lstStyle/>
           <a:p>
-            <a:endParaRPr lang="en-US"/>
+            <a:r>
+              <a:rPr lang="en-US"/>
+              <a:t>Vincenzo Gulisano</a:t>
+            </a:r>
           </a:p>
         </p:txBody>
       </p:sp>
@@ -10863,7 +10896,10 @@
             </a:lvl1pPr>
           </a:lstStyle>
           <a:p>
-            <a:endParaRPr lang="en-US"/>
+            <a:r>
+              <a:rPr lang="en-US"/>
+              <a:t>Vincenzo Gulisano</a:t>
+            </a:r>
           </a:p>
         </p:txBody>
       </p:sp>
@@ -10980,7 +11016,7 @@
     <p:sldLayoutId id="2147483665" r:id="rId12"/>
     <p:sldLayoutId id="2147483666" r:id="rId13"/>
   </p:sldLayoutIdLst>
-  <p:hf hdr="0" ftr="0" dt="0"/>
+  <p:hf hdr="0" ftr="0"/>
   <p:txStyles>
     <p:titleStyle>
       <a:lvl1pPr algn="l" defTabSz="914400" rtl="0" eaLnBrk="1" latinLnBrk="0" hangingPunct="1">
@@ -11335,88 +11371,104 @@
           </a:p>
         </p:txBody>
       </p:sp>
-      <p:pic>
-        <p:nvPicPr>
-          <p:cNvPr id="3078" name="Picture 6" descr="http://upload.wikimedia.org/wikipedia/en/5/5c/Chalmers_logo.png"/>
-          <p:cNvPicPr>
-            <a:picLocks noChangeAspect="1" noChangeArrowheads="1"/>
-          </p:cNvPicPr>
-          <p:nvPr/>
-        </p:nvPicPr>
-        <p:blipFill>
-          <a:blip r:embed="rId3">
+      <p:grpSp>
+        <p:nvGrpSpPr>
+          <p:cNvPr id="2" name="Group 1">
             <a:extLst>
-              <a:ext uri="{28A0092B-C50C-407E-A947-70E740481C1C}">
-                <a14:useLocalDpi xmlns:a14="http://schemas.microsoft.com/office/drawing/2010/main" val="0"/>
+              <a:ext uri="{FF2B5EF4-FFF2-40B4-BE49-F238E27FC236}">
+                <a16:creationId xmlns:a16="http://schemas.microsoft.com/office/drawing/2014/main" id="{DE77F173-1DA6-4223-61E1-FEDFE24BD549}"/>
               </a:ext>
             </a:extLst>
-          </a:blip>
-          <a:srcRect/>
-          <a:stretch>
-            <a:fillRect/>
-          </a:stretch>
-        </p:blipFill>
-        <p:spPr bwMode="auto">
+          </p:cNvPr>
+          <p:cNvGrpSpPr/>
+          <p:nvPr/>
+        </p:nvGrpSpPr>
+        <p:grpSpPr>
           <a:xfrm>
-            <a:off x="4100831" y="4512849"/>
-            <a:ext cx="1880870" cy="1747712"/>
+            <a:off x="2543614" y="4468860"/>
+            <a:ext cx="7104771" cy="1547400"/>
+            <a:chOff x="777241" y="4793437"/>
+            <a:chExt cx="7104771" cy="1547400"/>
           </a:xfrm>
-          <a:prstGeom prst="rect">
-            <a:avLst/>
-          </a:prstGeom>
-          <a:noFill/>
-          <a:extLst>
-            <a:ext uri="{909E8E84-426E-40DD-AFC4-6F175D3DCCD1}">
-              <a14:hiddenFill xmlns:a14="http://schemas.microsoft.com/office/drawing/2010/main">
-                <a:solidFill>
-                  <a:srgbClr val="FFFFFF"/>
-                </a:solidFill>
-              </a14:hiddenFill>
-            </a:ext>
-          </a:extLst>
-        </p:spPr>
-      </p:pic>
-      <p:pic>
-        <p:nvPicPr>
-          <p:cNvPr id="3080" name="Picture 8" descr="http://sgroup.be/sites/default/files/LOGUeng_cen2r.gif"/>
-          <p:cNvPicPr>
-            <a:picLocks noChangeAspect="1" noChangeArrowheads="1"/>
-          </p:cNvPicPr>
-          <p:nvPr/>
-        </p:nvPicPr>
-        <p:blipFill>
-          <a:blip r:embed="rId4">
+        </p:grpSpPr>
+        <p:pic>
+          <p:nvPicPr>
+            <p:cNvPr id="3" name="Picture 2">
+              <a:extLst>
+                <a:ext uri="{FF2B5EF4-FFF2-40B4-BE49-F238E27FC236}">
+                  <a16:creationId xmlns:a16="http://schemas.microsoft.com/office/drawing/2014/main" id="{3D79F06A-3449-CCAB-D741-749395BD7373}"/>
+                </a:ext>
+              </a:extLst>
+            </p:cNvPr>
+            <p:cNvPicPr>
+              <a:picLocks noChangeAspect="1" noChangeArrowheads="1"/>
+            </p:cNvPicPr>
+            <p:nvPr/>
+          </p:nvPicPr>
+          <p:blipFill>
+            <a:blip r:embed="rId3">
+              <a:extLst>
+                <a:ext uri="{28A0092B-C50C-407E-A947-70E740481C1C}">
+                  <a14:useLocalDpi xmlns:a14="http://schemas.microsoft.com/office/drawing/2010/main" val="0"/>
+                </a:ext>
+              </a:extLst>
+            </a:blip>
+            <a:srcRect/>
+            <a:stretch>
+              <a:fillRect/>
+            </a:stretch>
+          </p:blipFill>
+          <p:spPr bwMode="auto">
+            <a:xfrm>
+              <a:off x="5803022" y="4793437"/>
+              <a:ext cx="2078990" cy="1547400"/>
+            </a:xfrm>
+            <a:prstGeom prst="rect">
+              <a:avLst/>
+            </a:prstGeom>
+            <a:noFill/>
             <a:extLst>
-              <a:ext uri="{28A0092B-C50C-407E-A947-70E740481C1C}">
-                <a14:useLocalDpi xmlns:a14="http://schemas.microsoft.com/office/drawing/2010/main" val="0"/>
+              <a:ext uri="{909E8E84-426E-40DD-AFC4-6F175D3DCCD1}">
+                <a14:hiddenFill xmlns:a14="http://schemas.microsoft.com/office/drawing/2010/main">
+                  <a:solidFill>
+                    <a:srgbClr val="FFFFFF"/>
+                  </a:solidFill>
+                </a14:hiddenFill>
               </a:ext>
             </a:extLst>
-          </a:blip>
-          <a:srcRect/>
-          <a:stretch>
-            <a:fillRect/>
-          </a:stretch>
-        </p:blipFill>
-        <p:spPr bwMode="auto">
-          <a:xfrm>
-            <a:off x="6173471" y="4613005"/>
-            <a:ext cx="2078990" cy="1547400"/>
-          </a:xfrm>
-          <a:prstGeom prst="rect">
-            <a:avLst/>
-          </a:prstGeom>
-          <a:noFill/>
-          <a:extLst>
-            <a:ext uri="{909E8E84-426E-40DD-AFC4-6F175D3DCCD1}">
-              <a14:hiddenFill xmlns:a14="http://schemas.microsoft.com/office/drawing/2010/main">
-                <a:solidFill>
-                  <a:srgbClr val="FFFFFF"/>
-                </a:solidFill>
-              </a14:hiddenFill>
-            </a:ext>
-          </a:extLst>
-        </p:spPr>
-      </p:pic>
+          </p:spPr>
+        </p:pic>
+        <p:pic>
+          <p:nvPicPr>
+            <p:cNvPr id="4" name="Picture 3">
+              <a:extLst>
+                <a:ext uri="{FF2B5EF4-FFF2-40B4-BE49-F238E27FC236}">
+                  <a16:creationId xmlns:a16="http://schemas.microsoft.com/office/drawing/2014/main" id="{42649405-C12D-D2F0-F97F-F744386C276B}"/>
+                </a:ext>
+              </a:extLst>
+            </p:cNvPr>
+            <p:cNvPicPr>
+              <a:picLocks noChangeAspect="1"/>
+            </p:cNvPicPr>
+            <p:nvPr/>
+          </p:nvPicPr>
+          <p:blipFill>
+            <a:blip r:embed="rId4"/>
+            <a:stretch>
+              <a:fillRect/>
+            </a:stretch>
+          </p:blipFill>
+          <p:spPr>
+            <a:xfrm>
+              <a:off x="777241" y="4973870"/>
+              <a:ext cx="4724632" cy="1186535"/>
+            </a:xfrm>
+            <a:prstGeom prst="rect">
+              <a:avLst/>
+            </a:prstGeom>
+          </p:spPr>
+        </p:pic>
+      </p:grpSp>
     </p:spTree>
   </p:cSld>
   <p:clrMapOvr>
@@ -11692,6 +11744,34 @@
             <a:r>
               <a:rPr lang="en-US"/>
               <a:t>/thread</a:t>
+            </a:r>
+          </a:p>
+        </p:txBody>
+      </p:sp>
+      <p:sp>
+        <p:nvSpPr>
+          <p:cNvPr id="4" name="Date Placeholder 3">
+            <a:extLst>
+              <a:ext uri="{FF2B5EF4-FFF2-40B4-BE49-F238E27FC236}">
+                <a16:creationId xmlns:a16="http://schemas.microsoft.com/office/drawing/2014/main" id="{195A329A-2DA9-A207-3B1A-DC21278AC887}"/>
+              </a:ext>
+            </a:extLst>
+          </p:cNvPr>
+          <p:cNvSpPr>
+            <a:spLocks noGrp="1"/>
+          </p:cNvSpPr>
+          <p:nvPr>
+            <p:ph type="dt" sz="half" idx="10"/>
+          </p:nvPr>
+        </p:nvSpPr>
+        <p:spPr/>
+        <p:txBody>
+          <a:bodyPr/>
+          <a:lstStyle/>
+          <a:p>
+            <a:r>
+              <a:rPr lang="en-US"/>
+              <a:t>Vincenzo Gulisano</a:t>
             </a:r>
           </a:p>
         </p:txBody>
@@ -12948,6 +13028,34 @@
           </a:p>
         </p:txBody>
       </p:sp>
+      <p:sp>
+        <p:nvSpPr>
+          <p:cNvPr id="5" name="Date Placeholder 4">
+            <a:extLst>
+              <a:ext uri="{FF2B5EF4-FFF2-40B4-BE49-F238E27FC236}">
+                <a16:creationId xmlns:a16="http://schemas.microsoft.com/office/drawing/2014/main" id="{5BF15EE3-5310-7204-DA4C-314176D3E13C}"/>
+              </a:ext>
+            </a:extLst>
+          </p:cNvPr>
+          <p:cNvSpPr>
+            <a:spLocks noGrp="1"/>
+          </p:cNvSpPr>
+          <p:nvPr>
+            <p:ph type="dt" sz="half" idx="10"/>
+          </p:nvPr>
+        </p:nvSpPr>
+        <p:spPr/>
+        <p:txBody>
+          <a:bodyPr/>
+          <a:lstStyle/>
+          <a:p>
+            <a:r>
+              <a:rPr lang="en-US"/>
+              <a:t>Vincenzo Gulisano</a:t>
+            </a:r>
+          </a:p>
+        </p:txBody>
+      </p:sp>
     </p:spTree>
     <p:extLst>
       <p:ext uri="{BB962C8B-B14F-4D97-AF65-F5344CB8AC3E}">
@@ -13650,6 +13758,34 @@
               <a:t>check-competition approach</a:t>
             </a:r>
             <a:endParaRPr lang="sv-SE" dirty="0"/>
+          </a:p>
+        </p:txBody>
+      </p:sp>
+      <p:sp>
+        <p:nvSpPr>
+          <p:cNvPr id="2" name="Date Placeholder 1">
+            <a:extLst>
+              <a:ext uri="{FF2B5EF4-FFF2-40B4-BE49-F238E27FC236}">
+                <a16:creationId xmlns:a16="http://schemas.microsoft.com/office/drawing/2014/main" id="{17C55493-BD0C-F762-7CF4-CCCBBCFE7FB7}"/>
+              </a:ext>
+            </a:extLst>
+          </p:cNvPr>
+          <p:cNvSpPr>
+            <a:spLocks noGrp="1"/>
+          </p:cNvSpPr>
+          <p:nvPr>
+            <p:ph type="dt" sz="half" idx="10"/>
+          </p:nvPr>
+        </p:nvSpPr>
+        <p:spPr/>
+        <p:txBody>
+          <a:bodyPr/>
+          <a:lstStyle/>
+          <a:p>
+            <a:r>
+              <a:rPr lang="en-US"/>
+              <a:t>Vincenzo Gulisano</a:t>
+            </a:r>
           </a:p>
         </p:txBody>
       </p:sp>
@@ -14532,10 +14668,10 @@
           <p:nvPr/>
         </p:nvPicPr>
         <p:blipFill>
-          <a:blip r:embed="rId3">
+          <a:blip>
             <a:extLst>
               <a:ext uri="{96DAC541-7B7A-43D3-8B79-37D633B846F1}">
-                <asvg:svgBlip xmlns:asvg="http://schemas.microsoft.com/office/drawing/2016/SVG/main" r:embed="rId4"/>
+                <asvg:svgBlip xmlns:asvg="http://schemas.microsoft.com/office/drawing/2016/SVG/main" r:embed="rId3"/>
               </a:ext>
             </a:extLst>
           </a:blip>
@@ -14677,6 +14813,34 @@
               <a:t>13</a:t>
             </a:fld>
             <a:endParaRPr lang="en-US"/>
+          </a:p>
+        </p:txBody>
+      </p:sp>
+      <p:sp>
+        <p:nvSpPr>
+          <p:cNvPr id="4" name="Date Placeholder 3">
+            <a:extLst>
+              <a:ext uri="{FF2B5EF4-FFF2-40B4-BE49-F238E27FC236}">
+                <a16:creationId xmlns:a16="http://schemas.microsoft.com/office/drawing/2014/main" id="{8E4036EA-BA5D-0350-333B-5B34B07AE7CD}"/>
+              </a:ext>
+            </a:extLst>
+          </p:cNvPr>
+          <p:cNvSpPr>
+            <a:spLocks noGrp="1"/>
+          </p:cNvSpPr>
+          <p:nvPr>
+            <p:ph type="dt" sz="half" idx="10"/>
+          </p:nvPr>
+        </p:nvSpPr>
+        <p:spPr/>
+        <p:txBody>
+          <a:bodyPr/>
+          <a:lstStyle/>
+          <a:p>
+            <a:r>
+              <a:rPr lang="en-US"/>
+              <a:t>Vincenzo Gulisano</a:t>
+            </a:r>
           </a:p>
         </p:txBody>
       </p:sp>
@@ -14972,10 +15136,10 @@
           <p:nvPr/>
         </p:nvPicPr>
         <p:blipFill>
-          <a:blip r:embed="rId3">
+          <a:blip>
             <a:extLst>
               <a:ext uri="{96DAC541-7B7A-43D3-8B79-37D633B846F1}">
-                <asvg:svgBlip xmlns:asvg="http://schemas.microsoft.com/office/drawing/2016/SVG/main" r:embed="rId4"/>
+                <asvg:svgBlip xmlns:asvg="http://schemas.microsoft.com/office/drawing/2016/SVG/main" r:embed="rId3"/>
               </a:ext>
             </a:extLst>
           </a:blip>
@@ -16190,6 +16354,34 @@
           </a:p>
         </p:txBody>
       </p:sp>
+      <p:sp>
+        <p:nvSpPr>
+          <p:cNvPr id="3" name="Date Placeholder 2">
+            <a:extLst>
+              <a:ext uri="{FF2B5EF4-FFF2-40B4-BE49-F238E27FC236}">
+                <a16:creationId xmlns:a16="http://schemas.microsoft.com/office/drawing/2014/main" id="{88BACE61-AE58-09D9-EBC5-B0CA424EAFDC}"/>
+              </a:ext>
+            </a:extLst>
+          </p:cNvPr>
+          <p:cNvSpPr>
+            <a:spLocks noGrp="1"/>
+          </p:cNvSpPr>
+          <p:nvPr>
+            <p:ph type="dt" sz="half" idx="10"/>
+          </p:nvPr>
+        </p:nvSpPr>
+        <p:spPr/>
+        <p:txBody>
+          <a:bodyPr/>
+          <a:lstStyle/>
+          <a:p>
+            <a:r>
+              <a:rPr lang="en-US"/>
+              <a:t>Vincenzo Gulisano</a:t>
+            </a:r>
+          </a:p>
+        </p:txBody>
+      </p:sp>
     </p:spTree>
     <p:extLst>
       <p:ext uri="{BB962C8B-B14F-4D97-AF65-F5344CB8AC3E}">
@@ -16392,10 +16584,10 @@
           <p:nvPr/>
         </p:nvPicPr>
         <p:blipFill>
-          <a:blip r:embed="rId3">
+          <a:blip>
             <a:extLst>
               <a:ext uri="{96DAC541-7B7A-43D3-8B79-37D633B846F1}">
-                <asvg:svgBlip xmlns:asvg="http://schemas.microsoft.com/office/drawing/2016/SVG/main" r:embed="rId4"/>
+                <asvg:svgBlip xmlns:asvg="http://schemas.microsoft.com/office/drawing/2016/SVG/main" r:embed="rId3"/>
               </a:ext>
             </a:extLst>
           </a:blip>
@@ -17596,7 +17788,7 @@
           <p:nvPr/>
         </p:nvPicPr>
         <p:blipFill>
-          <a:blip r:embed="rId5">
+          <a:blip r:embed="rId4">
             <a:clrChange>
               <a:clrFrom>
                 <a:srgbClr val="FFFFFF"/>
@@ -17664,6 +17856,34 @@
               <a:t>15</a:t>
             </a:fld>
             <a:endParaRPr lang="en-US"/>
+          </a:p>
+        </p:txBody>
+      </p:sp>
+      <p:sp>
+        <p:nvSpPr>
+          <p:cNvPr id="4" name="Date Placeholder 3">
+            <a:extLst>
+              <a:ext uri="{FF2B5EF4-FFF2-40B4-BE49-F238E27FC236}">
+                <a16:creationId xmlns:a16="http://schemas.microsoft.com/office/drawing/2014/main" id="{ECFAF097-B3E2-5D98-C024-627971509A33}"/>
+              </a:ext>
+            </a:extLst>
+          </p:cNvPr>
+          <p:cNvSpPr>
+            <a:spLocks noGrp="1"/>
+          </p:cNvSpPr>
+          <p:nvPr>
+            <p:ph type="dt" sz="half" idx="10"/>
+          </p:nvPr>
+        </p:nvSpPr>
+        <p:spPr/>
+        <p:txBody>
+          <a:bodyPr/>
+          <a:lstStyle/>
+          <a:p>
+            <a:r>
+              <a:rPr lang="en-US"/>
+              <a:t>Vincenzo Gulisano</a:t>
+            </a:r>
           </a:p>
         </p:txBody>
       </p:sp>
@@ -17892,6 +18112,34 @@
           </a:p>
         </p:txBody>
       </p:sp>
+      <p:sp>
+        <p:nvSpPr>
+          <p:cNvPr id="5" name="Date Placeholder 4">
+            <a:extLst>
+              <a:ext uri="{FF2B5EF4-FFF2-40B4-BE49-F238E27FC236}">
+                <a16:creationId xmlns:a16="http://schemas.microsoft.com/office/drawing/2014/main" id="{BAF396B7-2BA7-F804-E6D1-FC7CD9081152}"/>
+              </a:ext>
+            </a:extLst>
+          </p:cNvPr>
+          <p:cNvSpPr>
+            <a:spLocks noGrp="1"/>
+          </p:cNvSpPr>
+          <p:nvPr>
+            <p:ph type="dt" sz="half" idx="10"/>
+          </p:nvPr>
+        </p:nvSpPr>
+        <p:spPr/>
+        <p:txBody>
+          <a:bodyPr/>
+          <a:lstStyle/>
+          <a:p>
+            <a:r>
+              <a:rPr lang="en-US"/>
+              <a:t>Vincenzo Gulisano</a:t>
+            </a:r>
+          </a:p>
+        </p:txBody>
+      </p:sp>
     </p:spTree>
     <p:extLst>
       <p:ext uri="{BB962C8B-B14F-4D97-AF65-F5344CB8AC3E}">
@@ -18531,6 +18779,34 @@
               <a:t>) approach</a:t>
             </a:r>
             <a:endParaRPr lang="sv-SE" dirty="0"/>
+          </a:p>
+        </p:txBody>
+      </p:sp>
+      <p:sp>
+        <p:nvSpPr>
+          <p:cNvPr id="2" name="Date Placeholder 1">
+            <a:extLst>
+              <a:ext uri="{FF2B5EF4-FFF2-40B4-BE49-F238E27FC236}">
+                <a16:creationId xmlns:a16="http://schemas.microsoft.com/office/drawing/2014/main" id="{5003AEA0-F203-64A8-9AD8-2542C4C05961}"/>
+              </a:ext>
+            </a:extLst>
+          </p:cNvPr>
+          <p:cNvSpPr>
+            <a:spLocks noGrp="1"/>
+          </p:cNvSpPr>
+          <p:nvPr>
+            <p:ph type="dt" sz="half" idx="10"/>
+          </p:nvPr>
+        </p:nvSpPr>
+        <p:spPr/>
+        <p:txBody>
+          <a:bodyPr/>
+          <a:lstStyle/>
+          <a:p>
+            <a:r>
+              <a:rPr lang="en-US"/>
+              <a:t>Vincenzo Gulisano</a:t>
+            </a:r>
           </a:p>
         </p:txBody>
       </p:sp>
@@ -18579,10 +18855,10 @@
           <p:nvPr/>
         </p:nvPicPr>
         <p:blipFill>
-          <a:blip r:embed="rId3">
+          <a:blip>
             <a:extLst>
               <a:ext uri="{96DAC541-7B7A-43D3-8B79-37D633B846F1}">
-                <asvg:svgBlip xmlns:asvg="http://schemas.microsoft.com/office/drawing/2016/SVG/main" r:embed="rId4"/>
+                <asvg:svgBlip xmlns:asvg="http://schemas.microsoft.com/office/drawing/2016/SVG/main" r:embed="rId3"/>
               </a:ext>
             </a:extLst>
           </a:blip>
@@ -19476,10 +19752,10 @@
           <p:nvPr/>
         </p:nvPicPr>
         <p:blipFill>
-          <a:blip r:embed="rId5">
+          <a:blip r:embed="rId4">
             <a:extLst>
               <a:ext uri="{837473B0-CC2E-450A-ABE3-18F120FF3D39}">
-                <a1611:picAttrSrcUrl xmlns:a1611="http://schemas.microsoft.com/office/drawing/2016/11/main" r:id="rId6"/>
+                <a1611:picAttrSrcUrl xmlns:a1611="http://schemas.microsoft.com/office/drawing/2016/11/main" r:id="rId5"/>
               </a:ext>
             </a:extLst>
           </a:blip>
@@ -19523,6 +19799,34 @@
               <a:t>18</a:t>
             </a:fld>
             <a:endParaRPr lang="en-US"/>
+          </a:p>
+        </p:txBody>
+      </p:sp>
+      <p:sp>
+        <p:nvSpPr>
+          <p:cNvPr id="3" name="Date Placeholder 2">
+            <a:extLst>
+              <a:ext uri="{FF2B5EF4-FFF2-40B4-BE49-F238E27FC236}">
+                <a16:creationId xmlns:a16="http://schemas.microsoft.com/office/drawing/2014/main" id="{1FC5CCF7-1409-935C-C59A-7C458F4070A3}"/>
+              </a:ext>
+            </a:extLst>
+          </p:cNvPr>
+          <p:cNvSpPr>
+            <a:spLocks noGrp="1"/>
+          </p:cNvSpPr>
+          <p:nvPr>
+            <p:ph type="dt" sz="half" idx="10"/>
+          </p:nvPr>
+        </p:nvSpPr>
+        <p:spPr/>
+        <p:txBody>
+          <a:bodyPr/>
+          <a:lstStyle/>
+          <a:p>
+            <a:r>
+              <a:rPr lang="en-US"/>
+              <a:t>Vincenzo Gulisano</a:t>
+            </a:r>
           </a:p>
         </p:txBody>
       </p:sp>
@@ -19736,10 +20040,10 @@
           <p:nvPr/>
         </p:nvPicPr>
         <p:blipFill>
-          <a:blip r:embed="rId3">
+          <a:blip>
             <a:extLst>
               <a:ext uri="{96DAC541-7B7A-43D3-8B79-37D633B846F1}">
-                <asvg:svgBlip xmlns:asvg="http://schemas.microsoft.com/office/drawing/2016/SVG/main" r:embed="rId4"/>
+                <asvg:svgBlip xmlns:asvg="http://schemas.microsoft.com/office/drawing/2016/SVG/main" r:embed="rId3"/>
               </a:ext>
             </a:extLst>
           </a:blip>
@@ -20865,33 +21169,33 @@
           <a:custGeom>
             <a:avLst/>
             <a:gdLst>
-              <a:gd name="connsiteX0" fmla="*/ 0 w 3995413"/>
-              <a:gd name="connsiteY0" fmla="*/ 0 h 4208118"/>
-              <a:gd name="connsiteX1" fmla="*/ 3995413 w 3995413"/>
-              <a:gd name="connsiteY1" fmla="*/ 0 h 4208118"/>
-              <a:gd name="connsiteX2" fmla="*/ 3995413 w 3995413"/>
-              <a:gd name="connsiteY2" fmla="*/ 4208118 h 4208118"/>
-              <a:gd name="connsiteX3" fmla="*/ 0 w 3995413"/>
-              <a:gd name="connsiteY3" fmla="*/ 4208118 h 4208118"/>
-              <a:gd name="connsiteX4" fmla="*/ 0 w 3995413"/>
-              <a:gd name="connsiteY4" fmla="*/ 0 h 4208118"/>
+              <a:gd name="csX0" fmla="*/ 0 w 3995413"/>
+              <a:gd name="csY0" fmla="*/ 0 h 4208118"/>
+              <a:gd name="csX1" fmla="*/ 3995413 w 3995413"/>
+              <a:gd name="csY1" fmla="*/ 0 h 4208118"/>
+              <a:gd name="csX2" fmla="*/ 3995413 w 3995413"/>
+              <a:gd name="csY2" fmla="*/ 4208118 h 4208118"/>
+              <a:gd name="csX3" fmla="*/ 0 w 3995413"/>
+              <a:gd name="csY3" fmla="*/ 4208118 h 4208118"/>
+              <a:gd name="csX4" fmla="*/ 0 w 3995413"/>
+              <a:gd name="csY4" fmla="*/ 0 h 4208118"/>
             </a:gdLst>
             <a:ahLst/>
             <a:cxnLst>
               <a:cxn ang="0">
-                <a:pos x="connsiteX0" y="connsiteY0"/>
+                <a:pos x="csX0" y="csY0"/>
               </a:cxn>
               <a:cxn ang="0">
-                <a:pos x="connsiteX1" y="connsiteY1"/>
+                <a:pos x="csX1" y="csY1"/>
               </a:cxn>
               <a:cxn ang="0">
-                <a:pos x="connsiteX2" y="connsiteY2"/>
+                <a:pos x="csX2" y="csY2"/>
               </a:cxn>
               <a:cxn ang="0">
-                <a:pos x="connsiteX3" y="connsiteY3"/>
+                <a:pos x="csX3" y="csY3"/>
               </a:cxn>
               <a:cxn ang="0">
-                <a:pos x="connsiteX4" y="connsiteY4"/>
+                <a:pos x="csX4" y="csY4"/>
               </a:cxn>
             </a:cxnLst>
             <a:rect l="l" t="t" r="r" b="b"/>
@@ -20994,6 +21298,34 @@
               <a:t>19</a:t>
             </a:fld>
             <a:endParaRPr lang="en-US"/>
+          </a:p>
+        </p:txBody>
+      </p:sp>
+      <p:sp>
+        <p:nvSpPr>
+          <p:cNvPr id="4" name="Date Placeholder 3">
+            <a:extLst>
+              <a:ext uri="{FF2B5EF4-FFF2-40B4-BE49-F238E27FC236}">
+                <a16:creationId xmlns:a16="http://schemas.microsoft.com/office/drawing/2014/main" id="{D1D5B559-2C99-2E8A-848D-4A6A08DF8F06}"/>
+              </a:ext>
+            </a:extLst>
+          </p:cNvPr>
+          <p:cNvSpPr>
+            <a:spLocks noGrp="1"/>
+          </p:cNvSpPr>
+          <p:nvPr>
+            <p:ph type="dt" sz="half" idx="10"/>
+          </p:nvPr>
+        </p:nvSpPr>
+        <p:spPr/>
+        <p:txBody>
+          <a:bodyPr/>
+          <a:lstStyle/>
+          <a:p>
+            <a:r>
+              <a:rPr lang="en-US"/>
+              <a:t>Vincenzo Gulisano</a:t>
+            </a:r>
           </a:p>
         </p:txBody>
       </p:sp>
@@ -21339,31 +21671,8 @@
           <a:lstStyle/>
           <a:p>
             <a:r>
-              <a:rPr lang="sv-SE"/>
+              <a:rPr lang="en-US"/>
               <a:t>Vincenzo Gulisano</a:t>
-            </a:r>
-            <a:endParaRPr lang="en-US"/>
-          </a:p>
-        </p:txBody>
-      </p:sp>
-      <p:sp>
-        <p:nvSpPr>
-          <p:cNvPr id="5" name="Footer Placeholder 4"/>
-          <p:cNvSpPr>
-            <a:spLocks noGrp="1"/>
-          </p:cNvSpPr>
-          <p:nvPr>
-            <p:ph type="ftr" sz="quarter" idx="11"/>
-          </p:nvPr>
-        </p:nvSpPr>
-        <p:spPr/>
-        <p:txBody>
-          <a:bodyPr/>
-          <a:lstStyle/>
-          <a:p>
-            <a:r>
-              <a:rPr lang="en-US"/>
-              <a:t>Operating Systems - Lecture 2 - Processes</a:t>
             </a:r>
           </a:p>
         </p:txBody>
@@ -21436,10 +21745,10 @@
           <p:nvPr/>
         </p:nvPicPr>
         <p:blipFill>
-          <a:blip r:embed="rId3">
+          <a:blip>
             <a:extLst>
               <a:ext uri="{96DAC541-7B7A-43D3-8B79-37D633B846F1}">
-                <asvg:svgBlip xmlns:asvg="http://schemas.microsoft.com/office/drawing/2016/SVG/main" r:embed="rId4"/>
+                <asvg:svgBlip xmlns:asvg="http://schemas.microsoft.com/office/drawing/2016/SVG/main" r:embed="rId3"/>
               </a:ext>
             </a:extLst>
           </a:blip>
@@ -22035,10 +22344,10 @@
           <p:nvPr/>
         </p:nvPicPr>
         <p:blipFill>
-          <a:blip r:embed="rId5">
+          <a:blip r:embed="rId4">
             <a:extLst>
               <a:ext uri="{837473B0-CC2E-450A-ABE3-18F120FF3D39}">
-                <a1611:picAttrSrcUrl xmlns:a1611="http://schemas.microsoft.com/office/drawing/2016/11/main" r:id="rId6"/>
+                <a1611:picAttrSrcUrl xmlns:a1611="http://schemas.microsoft.com/office/drawing/2016/11/main" r:id="rId5"/>
               </a:ext>
             </a:extLst>
           </a:blip>
@@ -22082,6 +22391,34 @@
               <a:t>20</a:t>
             </a:fld>
             <a:endParaRPr lang="en-US"/>
+          </a:p>
+        </p:txBody>
+      </p:sp>
+      <p:sp>
+        <p:nvSpPr>
+          <p:cNvPr id="4" name="Date Placeholder 3">
+            <a:extLst>
+              <a:ext uri="{FF2B5EF4-FFF2-40B4-BE49-F238E27FC236}">
+                <a16:creationId xmlns:a16="http://schemas.microsoft.com/office/drawing/2014/main" id="{33E7ECBC-7A5D-F837-FDFC-96E3699C4657}"/>
+              </a:ext>
+            </a:extLst>
+          </p:cNvPr>
+          <p:cNvSpPr>
+            <a:spLocks noGrp="1"/>
+          </p:cNvSpPr>
+          <p:nvPr>
+            <p:ph type="dt" sz="half" idx="10"/>
+          </p:nvPr>
+        </p:nvSpPr>
+        <p:spPr/>
+        <p:txBody>
+          <a:bodyPr/>
+          <a:lstStyle/>
+          <a:p>
+            <a:r>
+              <a:rPr lang="en-US"/>
+              <a:t>Vincenzo Gulisano</a:t>
+            </a:r>
           </a:p>
         </p:txBody>
       </p:sp>
@@ -22232,10 +22569,10 @@
           <p:nvPr/>
         </p:nvPicPr>
         <p:blipFill>
-          <a:blip r:embed="rId3">
+          <a:blip>
             <a:extLst>
               <a:ext uri="{96DAC541-7B7A-43D3-8B79-37D633B846F1}">
-                <asvg:svgBlip xmlns:asvg="http://schemas.microsoft.com/office/drawing/2016/SVG/main" r:embed="rId4"/>
+                <asvg:svgBlip xmlns:asvg="http://schemas.microsoft.com/office/drawing/2016/SVG/main" r:embed="rId3"/>
               </a:ext>
             </a:extLst>
           </a:blip>
@@ -22831,10 +23168,10 @@
           <p:nvPr/>
         </p:nvPicPr>
         <p:blipFill>
-          <a:blip r:embed="rId5">
+          <a:blip r:embed="rId4">
             <a:extLst>
               <a:ext uri="{837473B0-CC2E-450A-ABE3-18F120FF3D39}">
-                <a1611:picAttrSrcUrl xmlns:a1611="http://schemas.microsoft.com/office/drawing/2016/11/main" r:id="rId6"/>
+                <a1611:picAttrSrcUrl xmlns:a1611="http://schemas.microsoft.com/office/drawing/2016/11/main" r:id="rId5"/>
               </a:ext>
             </a:extLst>
           </a:blip>
@@ -22867,7 +23204,7 @@
           <p:nvPr/>
         </p:nvPicPr>
         <p:blipFill>
-          <a:blip r:embed="rId7">
+          <a:blip r:embed="rId6">
             <a:clrChange>
               <a:clrFrom>
                 <a:srgbClr val="FFFFFF"/>
@@ -22935,6 +23272,34 @@
               <a:t>21</a:t>
             </a:fld>
             <a:endParaRPr lang="en-US"/>
+          </a:p>
+        </p:txBody>
+      </p:sp>
+      <p:sp>
+        <p:nvSpPr>
+          <p:cNvPr id="4" name="Date Placeholder 3">
+            <a:extLst>
+              <a:ext uri="{FF2B5EF4-FFF2-40B4-BE49-F238E27FC236}">
+                <a16:creationId xmlns:a16="http://schemas.microsoft.com/office/drawing/2014/main" id="{30961991-94B5-9078-A19B-46A3E0C66CCB}"/>
+              </a:ext>
+            </a:extLst>
+          </p:cNvPr>
+          <p:cNvSpPr>
+            <a:spLocks noGrp="1"/>
+          </p:cNvSpPr>
+          <p:nvPr>
+            <p:ph type="dt" sz="half" idx="10"/>
+          </p:nvPr>
+        </p:nvSpPr>
+        <p:spPr/>
+        <p:txBody>
+          <a:bodyPr/>
+          <a:lstStyle/>
+          <a:p>
+            <a:r>
+              <a:rPr lang="en-US"/>
+              <a:t>Vincenzo Gulisano</a:t>
+            </a:r>
           </a:p>
         </p:txBody>
       </p:sp>
@@ -23163,6 +23528,34 @@
           </a:p>
         </p:txBody>
       </p:sp>
+      <p:sp>
+        <p:nvSpPr>
+          <p:cNvPr id="5" name="Date Placeholder 4">
+            <a:extLst>
+              <a:ext uri="{FF2B5EF4-FFF2-40B4-BE49-F238E27FC236}">
+                <a16:creationId xmlns:a16="http://schemas.microsoft.com/office/drawing/2014/main" id="{6A2E21A0-AC4B-1399-9F8C-065965FA98FC}"/>
+              </a:ext>
+            </a:extLst>
+          </p:cNvPr>
+          <p:cNvSpPr>
+            <a:spLocks noGrp="1"/>
+          </p:cNvSpPr>
+          <p:nvPr>
+            <p:ph type="dt" sz="half" idx="10"/>
+          </p:nvPr>
+        </p:nvSpPr>
+        <p:spPr/>
+        <p:txBody>
+          <a:bodyPr/>
+          <a:lstStyle/>
+          <a:p>
+            <a:r>
+              <a:rPr lang="en-US"/>
+              <a:t>Vincenzo Gulisano</a:t>
+            </a:r>
+          </a:p>
+        </p:txBody>
+      </p:sp>
     </p:spTree>
     <p:extLst>
       <p:ext uri="{BB962C8B-B14F-4D97-AF65-F5344CB8AC3E}">
@@ -23948,6 +24341,34 @@
               <a:t>) approach</a:t>
             </a:r>
             <a:endParaRPr lang="sv-SE" dirty="0"/>
+          </a:p>
+        </p:txBody>
+      </p:sp>
+      <p:sp>
+        <p:nvSpPr>
+          <p:cNvPr id="3" name="Date Placeholder 2">
+            <a:extLst>
+              <a:ext uri="{FF2B5EF4-FFF2-40B4-BE49-F238E27FC236}">
+                <a16:creationId xmlns:a16="http://schemas.microsoft.com/office/drawing/2014/main" id="{C0AFD284-39B2-FD6A-D4D1-186E07088292}"/>
+              </a:ext>
+            </a:extLst>
+          </p:cNvPr>
+          <p:cNvSpPr>
+            <a:spLocks noGrp="1"/>
+          </p:cNvSpPr>
+          <p:nvPr>
+            <p:ph type="dt" sz="half" idx="10"/>
+          </p:nvPr>
+        </p:nvSpPr>
+        <p:spPr/>
+        <p:txBody>
+          <a:bodyPr/>
+          <a:lstStyle/>
+          <a:p>
+            <a:r>
+              <a:rPr lang="en-US"/>
+              <a:t>Vincenzo Gulisano</a:t>
+            </a:r>
           </a:p>
         </p:txBody>
       </p:sp>
@@ -24264,10 +24685,10 @@
           <p:nvPr/>
         </p:nvPicPr>
         <p:blipFill>
-          <a:blip r:embed="rId3">
+          <a:blip>
             <a:extLst>
               <a:ext uri="{96DAC541-7B7A-43D3-8B79-37D633B846F1}">
-                <asvg:svgBlip xmlns:asvg="http://schemas.microsoft.com/office/drawing/2016/SVG/main" r:embed="rId4"/>
+                <asvg:svgBlip xmlns:asvg="http://schemas.microsoft.com/office/drawing/2016/SVG/main" r:embed="rId3"/>
               </a:ext>
             </a:extLst>
           </a:blip>
@@ -25481,10 +25902,10 @@
           <p:nvPr/>
         </p:nvPicPr>
         <p:blipFill>
-          <a:blip r:embed="rId5">
+          <a:blip r:embed="rId4">
             <a:extLst>
               <a:ext uri="{837473B0-CC2E-450A-ABE3-18F120FF3D39}">
-                <a1611:picAttrSrcUrl xmlns:a1611="http://schemas.microsoft.com/office/drawing/2016/11/main" r:id="rId6"/>
+                <a1611:picAttrSrcUrl xmlns:a1611="http://schemas.microsoft.com/office/drawing/2016/11/main" r:id="rId5"/>
               </a:ext>
             </a:extLst>
           </a:blip>
@@ -25528,6 +25949,34 @@
               <a:t>24</a:t>
             </a:fld>
             <a:endParaRPr lang="en-US"/>
+          </a:p>
+        </p:txBody>
+      </p:sp>
+      <p:sp>
+        <p:nvSpPr>
+          <p:cNvPr id="4" name="Date Placeholder 3">
+            <a:extLst>
+              <a:ext uri="{FF2B5EF4-FFF2-40B4-BE49-F238E27FC236}">
+                <a16:creationId xmlns:a16="http://schemas.microsoft.com/office/drawing/2014/main" id="{12670123-1BB6-F9A7-57B8-1F0100345376}"/>
+              </a:ext>
+            </a:extLst>
+          </p:cNvPr>
+          <p:cNvSpPr>
+            <a:spLocks noGrp="1"/>
+          </p:cNvSpPr>
+          <p:nvPr>
+            <p:ph type="dt" sz="half" idx="10"/>
+          </p:nvPr>
+        </p:nvSpPr>
+        <p:spPr/>
+        <p:txBody>
+          <a:bodyPr/>
+          <a:lstStyle/>
+          <a:p>
+            <a:r>
+              <a:rPr lang="en-US"/>
+              <a:t>Vincenzo Gulisano</a:t>
+            </a:r>
           </a:p>
         </p:txBody>
       </p:sp>
@@ -26008,10 +26457,10 @@
           <p:nvPr/>
         </p:nvPicPr>
         <p:blipFill>
-          <a:blip r:embed="rId3">
+          <a:blip>
             <a:extLst>
               <a:ext uri="{96DAC541-7B7A-43D3-8B79-37D633B846F1}">
-                <asvg:svgBlip xmlns:asvg="http://schemas.microsoft.com/office/drawing/2016/SVG/main" r:embed="rId4"/>
+                <asvg:svgBlip xmlns:asvg="http://schemas.microsoft.com/office/drawing/2016/SVG/main" r:embed="rId3"/>
               </a:ext>
             </a:extLst>
           </a:blip>
@@ -27056,10 +27505,10 @@
           <p:nvPr/>
         </p:nvPicPr>
         <p:blipFill>
-          <a:blip r:embed="rId5">
+          <a:blip r:embed="rId4">
             <a:extLst>
               <a:ext uri="{837473B0-CC2E-450A-ABE3-18F120FF3D39}">
-                <a1611:picAttrSrcUrl xmlns:a1611="http://schemas.microsoft.com/office/drawing/2016/11/main" r:id="rId6"/>
+                <a1611:picAttrSrcUrl xmlns:a1611="http://schemas.microsoft.com/office/drawing/2016/11/main" r:id="rId5"/>
               </a:ext>
             </a:extLst>
           </a:blip>
@@ -27460,6 +27909,34 @@
           </a:fontRef>
         </p:style>
       </p:cxnSp>
+      <p:sp>
+        <p:nvSpPr>
+          <p:cNvPr id="2" name="Date Placeholder 1">
+            <a:extLst>
+              <a:ext uri="{FF2B5EF4-FFF2-40B4-BE49-F238E27FC236}">
+                <a16:creationId xmlns:a16="http://schemas.microsoft.com/office/drawing/2014/main" id="{96A1946D-9133-D0AD-5DCC-401372ADEB8B}"/>
+              </a:ext>
+            </a:extLst>
+          </p:cNvPr>
+          <p:cNvSpPr>
+            <a:spLocks noGrp="1"/>
+          </p:cNvSpPr>
+          <p:nvPr>
+            <p:ph type="dt" sz="half" idx="10"/>
+          </p:nvPr>
+        </p:nvSpPr>
+        <p:spPr/>
+        <p:txBody>
+          <a:bodyPr/>
+          <a:lstStyle/>
+          <a:p>
+            <a:r>
+              <a:rPr lang="en-US"/>
+              <a:t>Vincenzo Gulisano</a:t>
+            </a:r>
+          </a:p>
+        </p:txBody>
+      </p:sp>
     </p:spTree>
     <p:extLst>
       <p:ext uri="{BB962C8B-B14F-4D97-AF65-F5344CB8AC3E}">
@@ -27946,10 +28423,10 @@
           <p:nvPr/>
         </p:nvPicPr>
         <p:blipFill>
-          <a:blip r:embed="rId3">
+          <a:blip>
             <a:extLst>
               <a:ext uri="{96DAC541-7B7A-43D3-8B79-37D633B846F1}">
-                <asvg:svgBlip xmlns:asvg="http://schemas.microsoft.com/office/drawing/2016/SVG/main" r:embed="rId4"/>
+                <asvg:svgBlip xmlns:asvg="http://schemas.microsoft.com/office/drawing/2016/SVG/main" r:embed="rId3"/>
               </a:ext>
             </a:extLst>
           </a:blip>
@@ -28479,10 +28956,10 @@
           <p:nvPr/>
         </p:nvPicPr>
         <p:blipFill>
-          <a:blip r:embed="rId5">
+          <a:blip r:embed="rId4">
             <a:extLst>
               <a:ext uri="{837473B0-CC2E-450A-ABE3-18F120FF3D39}">
-                <a1611:picAttrSrcUrl xmlns:a1611="http://schemas.microsoft.com/office/drawing/2016/11/main" r:id="rId6"/>
+                <a1611:picAttrSrcUrl xmlns:a1611="http://schemas.microsoft.com/office/drawing/2016/11/main" r:id="rId5"/>
               </a:ext>
             </a:extLst>
           </a:blip>
@@ -28515,10 +28992,10 @@
           <p:nvPr/>
         </p:nvPicPr>
         <p:blipFill>
-          <a:blip r:embed="rId7">
+          <a:blip r:embed="rId6">
             <a:extLst>
               <a:ext uri="{837473B0-CC2E-450A-ABE3-18F120FF3D39}">
-                <a1611:picAttrSrcUrl xmlns:a1611="http://schemas.microsoft.com/office/drawing/2016/11/main" r:id="rId8"/>
+                <a1611:picAttrSrcUrl xmlns:a1611="http://schemas.microsoft.com/office/drawing/2016/11/main" r:id="rId7"/>
               </a:ext>
             </a:extLst>
           </a:blip>
@@ -28588,6 +29065,34 @@
                 </a:solidFill>
               </a:rPr>
               <a:t> B in RS</a:t>
+            </a:r>
+          </a:p>
+        </p:txBody>
+      </p:sp>
+      <p:sp>
+        <p:nvSpPr>
+          <p:cNvPr id="2" name="Date Placeholder 1">
+            <a:extLst>
+              <a:ext uri="{FF2B5EF4-FFF2-40B4-BE49-F238E27FC236}">
+                <a16:creationId xmlns:a16="http://schemas.microsoft.com/office/drawing/2014/main" id="{B43E847D-57DD-88F2-282F-A3981B3D0EC4}"/>
+              </a:ext>
+            </a:extLst>
+          </p:cNvPr>
+          <p:cNvSpPr>
+            <a:spLocks noGrp="1"/>
+          </p:cNvSpPr>
+          <p:nvPr>
+            <p:ph type="dt" sz="half" idx="10"/>
+          </p:nvPr>
+        </p:nvSpPr>
+        <p:spPr/>
+        <p:txBody>
+          <a:bodyPr/>
+          <a:lstStyle/>
+          <a:p>
+            <a:r>
+              <a:rPr lang="en-US"/>
+              <a:t>Vincenzo Gulisano</a:t>
             </a:r>
           </a:p>
         </p:txBody>
@@ -28937,10 +29442,10 @@
           <p:nvPr/>
         </p:nvPicPr>
         <p:blipFill>
-          <a:blip r:embed="rId3">
+          <a:blip>
             <a:extLst>
               <a:ext uri="{96DAC541-7B7A-43D3-8B79-37D633B846F1}">
-                <asvg:svgBlip xmlns:asvg="http://schemas.microsoft.com/office/drawing/2016/SVG/main" r:embed="rId4"/>
+                <asvg:svgBlip xmlns:asvg="http://schemas.microsoft.com/office/drawing/2016/SVG/main" r:embed="rId3"/>
               </a:ext>
             </a:extLst>
           </a:blip>
@@ -30305,10 +30810,10 @@
           <p:nvPr/>
         </p:nvPicPr>
         <p:blipFill>
-          <a:blip r:embed="rId5">
+          <a:blip r:embed="rId4">
             <a:extLst>
               <a:ext uri="{837473B0-CC2E-450A-ABE3-18F120FF3D39}">
-                <a1611:picAttrSrcUrl xmlns:a1611="http://schemas.microsoft.com/office/drawing/2016/11/main" r:id="rId6"/>
+                <a1611:picAttrSrcUrl xmlns:a1611="http://schemas.microsoft.com/office/drawing/2016/11/main" r:id="rId5"/>
               </a:ext>
             </a:extLst>
           </a:blip>
@@ -30326,6 +30831,34 @@
           </a:prstGeom>
         </p:spPr>
       </p:pic>
+      <p:sp>
+        <p:nvSpPr>
+          <p:cNvPr id="2" name="Date Placeholder 1">
+            <a:extLst>
+              <a:ext uri="{FF2B5EF4-FFF2-40B4-BE49-F238E27FC236}">
+                <a16:creationId xmlns:a16="http://schemas.microsoft.com/office/drawing/2014/main" id="{2A80CC11-EC85-6888-7D13-E9F1A4AEC455}"/>
+              </a:ext>
+            </a:extLst>
+          </p:cNvPr>
+          <p:cNvSpPr>
+            <a:spLocks noGrp="1"/>
+          </p:cNvSpPr>
+          <p:nvPr>
+            <p:ph type="dt" sz="half" idx="10"/>
+          </p:nvPr>
+        </p:nvSpPr>
+        <p:spPr/>
+        <p:txBody>
+          <a:bodyPr/>
+          <a:lstStyle/>
+          <a:p>
+            <a:r>
+              <a:rPr lang="en-US"/>
+              <a:t>Vincenzo Gulisano</a:t>
+            </a:r>
+          </a:p>
+        </p:txBody>
+      </p:sp>
     </p:spTree>
     <p:extLst>
       <p:ext uri="{BB962C8B-B14F-4D97-AF65-F5344CB8AC3E}">
@@ -31182,6 +31715,34 @@
           </a:p>
         </p:txBody>
       </p:sp>
+      <p:sp>
+        <p:nvSpPr>
+          <p:cNvPr id="5" name="Date Placeholder 4">
+            <a:extLst>
+              <a:ext uri="{FF2B5EF4-FFF2-40B4-BE49-F238E27FC236}">
+                <a16:creationId xmlns:a16="http://schemas.microsoft.com/office/drawing/2014/main" id="{AEDFC993-C53F-3474-D722-26BF2BC4DAE7}"/>
+              </a:ext>
+            </a:extLst>
+          </p:cNvPr>
+          <p:cNvSpPr>
+            <a:spLocks noGrp="1"/>
+          </p:cNvSpPr>
+          <p:nvPr>
+            <p:ph type="dt" sz="half" idx="10"/>
+          </p:nvPr>
+        </p:nvSpPr>
+        <p:spPr/>
+        <p:txBody>
+          <a:bodyPr/>
+          <a:lstStyle/>
+          <a:p>
+            <a:r>
+              <a:rPr lang="en-US"/>
+              <a:t>Vincenzo Gulisano</a:t>
+            </a:r>
+          </a:p>
+        </p:txBody>
+      </p:sp>
     </p:spTree>
     <p:extLst>
       <p:ext uri="{BB962C8B-B14F-4D97-AF65-F5344CB8AC3E}">
@@ -31398,6 +31959,34 @@
               <a:t>29</a:t>
             </a:fld>
             <a:endParaRPr lang="en-US"/>
+          </a:p>
+        </p:txBody>
+      </p:sp>
+      <p:sp>
+        <p:nvSpPr>
+          <p:cNvPr id="5" name="Date Placeholder 4">
+            <a:extLst>
+              <a:ext uri="{FF2B5EF4-FFF2-40B4-BE49-F238E27FC236}">
+                <a16:creationId xmlns:a16="http://schemas.microsoft.com/office/drawing/2014/main" id="{16BB206C-7083-4A51-41D6-584C0CF2DD57}"/>
+              </a:ext>
+            </a:extLst>
+          </p:cNvPr>
+          <p:cNvSpPr>
+            <a:spLocks noGrp="1"/>
+          </p:cNvSpPr>
+          <p:nvPr>
+            <p:ph type="dt" sz="half" idx="10"/>
+          </p:nvPr>
+        </p:nvSpPr>
+        <p:spPr/>
+        <p:txBody>
+          <a:bodyPr/>
+          <a:lstStyle/>
+          <a:p>
+            <a:r>
+              <a:rPr lang="en-US"/>
+              <a:t>Vincenzo Gulisano</a:t>
+            </a:r>
           </a:p>
         </p:txBody>
       </p:sp>
@@ -31578,6 +32167,34 @@
           </a:p>
         </p:txBody>
       </p:sp>
+      <p:sp>
+        <p:nvSpPr>
+          <p:cNvPr id="5" name="Date Placeholder 4">
+            <a:extLst>
+              <a:ext uri="{FF2B5EF4-FFF2-40B4-BE49-F238E27FC236}">
+                <a16:creationId xmlns:a16="http://schemas.microsoft.com/office/drawing/2014/main" id="{250FF07C-441C-9402-4788-85FB5CF6AA46}"/>
+              </a:ext>
+            </a:extLst>
+          </p:cNvPr>
+          <p:cNvSpPr>
+            <a:spLocks noGrp="1"/>
+          </p:cNvSpPr>
+          <p:nvPr>
+            <p:ph type="dt" sz="half" idx="10"/>
+          </p:nvPr>
+        </p:nvSpPr>
+        <p:spPr/>
+        <p:txBody>
+          <a:bodyPr/>
+          <a:lstStyle/>
+          <a:p>
+            <a:r>
+              <a:rPr lang="en-US"/>
+              <a:t>Vincenzo Gulisano</a:t>
+            </a:r>
+          </a:p>
+        </p:txBody>
+      </p:sp>
     </p:spTree>
     <p:extLst>
       <p:ext uri="{BB962C8B-B14F-4D97-AF65-F5344CB8AC3E}">
@@ -31904,7 +32521,7 @@
             <a:prstTxWarp prst="textNoShape">
               <a:avLst/>
             </a:prstTxWarp>
-            <a:normAutofit fontScale="85000" lnSpcReduction="10000"/>
+            <a:normAutofit fontScale="92500"/>
           </a:bodyPr>
           <a:lstStyle>
             <a:lvl1pPr algn="l" defTabSz="914400" rtl="0" eaLnBrk="1" latinLnBrk="0" hangingPunct="1">
@@ -32322,6 +32939,34 @@
                 <a:prstClr val="black"/>
               </a:solidFill>
             </a:endParaRPr>
+          </a:p>
+        </p:txBody>
+      </p:sp>
+      <p:sp>
+        <p:nvSpPr>
+          <p:cNvPr id="3" name="Date Placeholder 2">
+            <a:extLst>
+              <a:ext uri="{FF2B5EF4-FFF2-40B4-BE49-F238E27FC236}">
+                <a16:creationId xmlns:a16="http://schemas.microsoft.com/office/drawing/2014/main" id="{969F46F4-777F-8D5F-2228-F40D8E0C91EC}"/>
+              </a:ext>
+            </a:extLst>
+          </p:cNvPr>
+          <p:cNvSpPr>
+            <a:spLocks noGrp="1"/>
+          </p:cNvSpPr>
+          <p:nvPr>
+            <p:ph type="dt" sz="half" idx="10"/>
+          </p:nvPr>
+        </p:nvSpPr>
+        <p:spPr/>
+        <p:txBody>
+          <a:bodyPr/>
+          <a:lstStyle/>
+          <a:p>
+            <a:r>
+              <a:rPr lang="en-US"/>
+              <a:t>Vincenzo Gulisano</a:t>
+            </a:r>
           </a:p>
         </p:txBody>
       </p:sp>
@@ -33918,7 +34563,7 @@
             <a:prstTxWarp prst="textNoShape">
               <a:avLst/>
             </a:prstTxWarp>
-            <a:normAutofit fontScale="70000" lnSpcReduction="20000"/>
+            <a:normAutofit fontScale="77500" lnSpcReduction="20000"/>
           </a:bodyPr>
           <a:lstStyle>
             <a:lvl1pPr algn="l" defTabSz="914400" rtl="0" eaLnBrk="1" latinLnBrk="0" hangingPunct="1">
@@ -33962,6 +34607,34 @@
                 </a:schemeClr>
               </a:solidFill>
             </a:endParaRPr>
+          </a:p>
+        </p:txBody>
+      </p:sp>
+      <p:sp>
+        <p:nvSpPr>
+          <p:cNvPr id="3" name="Date Placeholder 2">
+            <a:extLst>
+              <a:ext uri="{FF2B5EF4-FFF2-40B4-BE49-F238E27FC236}">
+                <a16:creationId xmlns:a16="http://schemas.microsoft.com/office/drawing/2014/main" id="{4FF3762C-91DB-91F7-8CFD-594F2B5BA6CA}"/>
+              </a:ext>
+            </a:extLst>
+          </p:cNvPr>
+          <p:cNvSpPr>
+            <a:spLocks noGrp="1"/>
+          </p:cNvSpPr>
+          <p:nvPr>
+            <p:ph type="dt" sz="half" idx="10"/>
+          </p:nvPr>
+        </p:nvSpPr>
+        <p:spPr/>
+        <p:txBody>
+          <a:bodyPr/>
+          <a:lstStyle/>
+          <a:p>
+            <a:r>
+              <a:rPr lang="en-US"/>
+              <a:t>Vincenzo Gulisano</a:t>
+            </a:r>
           </a:p>
         </p:txBody>
       </p:sp>
@@ -36460,7 +37133,7 @@
             <a:prstTxWarp prst="textNoShape">
               <a:avLst/>
             </a:prstTxWarp>
-            <a:normAutofit fontScale="70000" lnSpcReduction="20000"/>
+            <a:normAutofit fontScale="77500" lnSpcReduction="20000"/>
           </a:bodyPr>
           <a:lstStyle>
             <a:lvl1pPr algn="l" defTabSz="914400" rtl="0" eaLnBrk="1" latinLnBrk="0" hangingPunct="1">
@@ -36504,6 +37177,34 @@
                 </a:schemeClr>
               </a:solidFill>
             </a:endParaRPr>
+          </a:p>
+        </p:txBody>
+      </p:sp>
+      <p:sp>
+        <p:nvSpPr>
+          <p:cNvPr id="2" name="Date Placeholder 1">
+            <a:extLst>
+              <a:ext uri="{FF2B5EF4-FFF2-40B4-BE49-F238E27FC236}">
+                <a16:creationId xmlns:a16="http://schemas.microsoft.com/office/drawing/2014/main" id="{E0839D43-5589-6D24-192D-2F068CDDE360}"/>
+              </a:ext>
+            </a:extLst>
+          </p:cNvPr>
+          <p:cNvSpPr>
+            <a:spLocks noGrp="1"/>
+          </p:cNvSpPr>
+          <p:nvPr>
+            <p:ph type="dt" sz="half" idx="10"/>
+          </p:nvPr>
+        </p:nvSpPr>
+        <p:spPr/>
+        <p:txBody>
+          <a:bodyPr/>
+          <a:lstStyle/>
+          <a:p>
+            <a:r>
+              <a:rPr lang="en-US"/>
+              <a:t>Vincenzo Gulisano</a:t>
+            </a:r>
           </a:p>
         </p:txBody>
       </p:sp>
@@ -36945,6 +37646,34 @@
                 </a:schemeClr>
               </a:solidFill>
             </a:endParaRPr>
+          </a:p>
+        </p:txBody>
+      </p:sp>
+      <p:sp>
+        <p:nvSpPr>
+          <p:cNvPr id="2" name="Date Placeholder 1">
+            <a:extLst>
+              <a:ext uri="{FF2B5EF4-FFF2-40B4-BE49-F238E27FC236}">
+                <a16:creationId xmlns:a16="http://schemas.microsoft.com/office/drawing/2014/main" id="{ED9401B8-C34A-EA0A-3712-7610BBC389BB}"/>
+              </a:ext>
+            </a:extLst>
+          </p:cNvPr>
+          <p:cNvSpPr>
+            <a:spLocks noGrp="1"/>
+          </p:cNvSpPr>
+          <p:nvPr>
+            <p:ph type="dt" sz="half" idx="10"/>
+          </p:nvPr>
+        </p:nvSpPr>
+        <p:spPr/>
+        <p:txBody>
+          <a:bodyPr/>
+          <a:lstStyle/>
+          <a:p>
+            <a:r>
+              <a:rPr lang="en-US"/>
+              <a:t>Vincenzo Gulisano</a:t>
+            </a:r>
           </a:p>
         </p:txBody>
       </p:sp>
@@ -38438,6 +39167,34 @@
           </a:p>
         </p:txBody>
       </p:sp>
+      <p:sp>
+        <p:nvSpPr>
+          <p:cNvPr id="3" name="Date Placeholder 2">
+            <a:extLst>
+              <a:ext uri="{FF2B5EF4-FFF2-40B4-BE49-F238E27FC236}">
+                <a16:creationId xmlns:a16="http://schemas.microsoft.com/office/drawing/2014/main" id="{F8C66E5E-CDAB-0D12-038B-8AB3AEF7C160}"/>
+              </a:ext>
+            </a:extLst>
+          </p:cNvPr>
+          <p:cNvSpPr>
+            <a:spLocks noGrp="1"/>
+          </p:cNvSpPr>
+          <p:nvPr>
+            <p:ph type="dt" sz="half" idx="10"/>
+          </p:nvPr>
+        </p:nvSpPr>
+        <p:spPr/>
+        <p:txBody>
+          <a:bodyPr/>
+          <a:lstStyle/>
+          <a:p>
+            <a:r>
+              <a:rPr lang="en-US"/>
+              <a:t>Vincenzo Gulisano</a:t>
+            </a:r>
+          </a:p>
+        </p:txBody>
+      </p:sp>
     </p:spTree>
     <p:extLst>
       <p:ext uri="{BB962C8B-B14F-4D97-AF65-F5344CB8AC3E}">
@@ -38667,6 +39424,34 @@
               <a:t>35</a:t>
             </a:fld>
             <a:endParaRPr lang="en-US"/>
+          </a:p>
+        </p:txBody>
+      </p:sp>
+      <p:sp>
+        <p:nvSpPr>
+          <p:cNvPr id="5" name="Date Placeholder 4">
+            <a:extLst>
+              <a:ext uri="{FF2B5EF4-FFF2-40B4-BE49-F238E27FC236}">
+                <a16:creationId xmlns:a16="http://schemas.microsoft.com/office/drawing/2014/main" id="{E2080648-2C6A-43ED-3C78-8CBFFBBBEBE9}"/>
+              </a:ext>
+            </a:extLst>
+          </p:cNvPr>
+          <p:cNvSpPr>
+            <a:spLocks noGrp="1"/>
+          </p:cNvSpPr>
+          <p:nvPr>
+            <p:ph type="dt" sz="half" idx="10"/>
+          </p:nvPr>
+        </p:nvSpPr>
+        <p:spPr/>
+        <p:txBody>
+          <a:bodyPr/>
+          <a:lstStyle/>
+          <a:p>
+            <a:r>
+              <a:rPr lang="en-US"/>
+              <a:t>Vincenzo Gulisano</a:t>
+            </a:r>
           </a:p>
         </p:txBody>
       </p:sp>
@@ -39845,13 +40630,13 @@
           <p:nvPr/>
         </p:nvPicPr>
         <p:blipFill>
-          <a:blip r:embed="rId3">
+          <a:blip>
             <a:extLst>
               <a:ext uri="{28A0092B-C50C-407E-A947-70E740481C1C}">
                 <a14:useLocalDpi xmlns:a14="http://schemas.microsoft.com/office/drawing/2010/main" val="0"/>
               </a:ext>
               <a:ext uri="{96DAC541-7B7A-43D3-8B79-37D633B846F1}">
-                <asvg:svgBlip xmlns:asvg="http://schemas.microsoft.com/office/drawing/2016/SVG/main" r:embed="rId4"/>
+                <asvg:svgBlip xmlns:asvg="http://schemas.microsoft.com/office/drawing/2016/SVG/main" r:embed="rId3"/>
               </a:ext>
             </a:extLst>
           </a:blip>
@@ -39884,13 +40669,13 @@
           <p:nvPr/>
         </p:nvPicPr>
         <p:blipFill>
-          <a:blip r:embed="rId3">
+          <a:blip>
             <a:extLst>
               <a:ext uri="{28A0092B-C50C-407E-A947-70E740481C1C}">
                 <a14:useLocalDpi xmlns:a14="http://schemas.microsoft.com/office/drawing/2010/main" val="0"/>
               </a:ext>
               <a:ext uri="{96DAC541-7B7A-43D3-8B79-37D633B846F1}">
-                <asvg:svgBlip xmlns:asvg="http://schemas.microsoft.com/office/drawing/2016/SVG/main" r:embed="rId4"/>
+                <asvg:svgBlip xmlns:asvg="http://schemas.microsoft.com/office/drawing/2016/SVG/main" r:embed="rId3"/>
               </a:ext>
             </a:extLst>
           </a:blip>
@@ -39987,6 +40772,34 @@
                 </a:schemeClr>
               </a:solidFill>
             </a:endParaRPr>
+          </a:p>
+        </p:txBody>
+      </p:sp>
+      <p:sp>
+        <p:nvSpPr>
+          <p:cNvPr id="7" name="Date Placeholder 6">
+            <a:extLst>
+              <a:ext uri="{FF2B5EF4-FFF2-40B4-BE49-F238E27FC236}">
+                <a16:creationId xmlns:a16="http://schemas.microsoft.com/office/drawing/2014/main" id="{9814F6B1-FDC1-0EC4-A659-2E55F1B3AE6C}"/>
+              </a:ext>
+            </a:extLst>
+          </p:cNvPr>
+          <p:cNvSpPr>
+            <a:spLocks noGrp="1"/>
+          </p:cNvSpPr>
+          <p:nvPr>
+            <p:ph type="dt" sz="half" idx="10"/>
+          </p:nvPr>
+        </p:nvSpPr>
+        <p:spPr/>
+        <p:txBody>
+          <a:bodyPr/>
+          <a:lstStyle/>
+          <a:p>
+            <a:r>
+              <a:rPr lang="en-US"/>
+              <a:t>Vincenzo Gulisano</a:t>
+            </a:r>
           </a:p>
         </p:txBody>
       </p:sp>
@@ -40783,6 +41596,34 @@
           </a:p>
         </p:txBody>
       </p:sp>
+      <p:sp>
+        <p:nvSpPr>
+          <p:cNvPr id="2" name="Date Placeholder 1">
+            <a:extLst>
+              <a:ext uri="{FF2B5EF4-FFF2-40B4-BE49-F238E27FC236}">
+                <a16:creationId xmlns:a16="http://schemas.microsoft.com/office/drawing/2014/main" id="{7E844D0A-D191-734A-DA31-271D06471E24}"/>
+              </a:ext>
+            </a:extLst>
+          </p:cNvPr>
+          <p:cNvSpPr>
+            <a:spLocks noGrp="1"/>
+          </p:cNvSpPr>
+          <p:nvPr>
+            <p:ph type="dt" sz="half" idx="10"/>
+          </p:nvPr>
+        </p:nvSpPr>
+        <p:spPr/>
+        <p:txBody>
+          <a:bodyPr/>
+          <a:lstStyle/>
+          <a:p>
+            <a:r>
+              <a:rPr lang="en-US"/>
+              <a:t>Vincenzo Gulisano</a:t>
+            </a:r>
+          </a:p>
+        </p:txBody>
+      </p:sp>
     </p:spTree>
     <p:extLst>
       <p:ext uri="{BB962C8B-B14F-4D97-AF65-F5344CB8AC3E}">
@@ -41328,6 +42169,34 @@
               <a:ea typeface="+mn-ea"/>
               <a:cs typeface="+mn-cs"/>
             </a:endParaRPr>
+          </a:p>
+        </p:txBody>
+      </p:sp>
+      <p:sp>
+        <p:nvSpPr>
+          <p:cNvPr id="2" name="Date Placeholder 1">
+            <a:extLst>
+              <a:ext uri="{FF2B5EF4-FFF2-40B4-BE49-F238E27FC236}">
+                <a16:creationId xmlns:a16="http://schemas.microsoft.com/office/drawing/2014/main" id="{DAB68789-C7D3-99D3-CD87-00DB00139FB8}"/>
+              </a:ext>
+            </a:extLst>
+          </p:cNvPr>
+          <p:cNvSpPr>
+            <a:spLocks noGrp="1"/>
+          </p:cNvSpPr>
+          <p:nvPr>
+            <p:ph type="dt" sz="half" idx="10"/>
+          </p:nvPr>
+        </p:nvSpPr>
+        <p:spPr/>
+        <p:txBody>
+          <a:bodyPr/>
+          <a:lstStyle/>
+          <a:p>
+            <a:r>
+              <a:rPr lang="en-US"/>
+              <a:t>Vincenzo Gulisano</a:t>
+            </a:r>
           </a:p>
         </p:txBody>
       </p:sp>
@@ -41758,6 +42627,34 @@
           </a:p>
         </p:txBody>
       </p:sp>
+      <p:sp>
+        <p:nvSpPr>
+          <p:cNvPr id="5" name="Date Placeholder 4">
+            <a:extLst>
+              <a:ext uri="{FF2B5EF4-FFF2-40B4-BE49-F238E27FC236}">
+                <a16:creationId xmlns:a16="http://schemas.microsoft.com/office/drawing/2014/main" id="{60686EA4-3EF2-9CCB-9B69-DE20621C290E}"/>
+              </a:ext>
+            </a:extLst>
+          </p:cNvPr>
+          <p:cNvSpPr>
+            <a:spLocks noGrp="1"/>
+          </p:cNvSpPr>
+          <p:nvPr>
+            <p:ph type="dt" sz="half" idx="10"/>
+          </p:nvPr>
+        </p:nvSpPr>
+        <p:spPr/>
+        <p:txBody>
+          <a:bodyPr/>
+          <a:lstStyle/>
+          <a:p>
+            <a:r>
+              <a:rPr lang="en-US"/>
+              <a:t>Vincenzo Gulisano</a:t>
+            </a:r>
+          </a:p>
+        </p:txBody>
+      </p:sp>
     </p:spTree>
     <p:extLst>
       <p:ext uri="{BB962C8B-B14F-4D97-AF65-F5344CB8AC3E}">
@@ -41980,6 +42877,34 @@
               <a:t>4</a:t>
             </a:fld>
             <a:endParaRPr lang="en-US"/>
+          </a:p>
+        </p:txBody>
+      </p:sp>
+      <p:sp>
+        <p:nvSpPr>
+          <p:cNvPr id="5" name="Date Placeholder 4">
+            <a:extLst>
+              <a:ext uri="{FF2B5EF4-FFF2-40B4-BE49-F238E27FC236}">
+                <a16:creationId xmlns:a16="http://schemas.microsoft.com/office/drawing/2014/main" id="{A49C7B4E-7AA0-2BAF-DDA0-08940A8C5E6E}"/>
+              </a:ext>
+            </a:extLst>
+          </p:cNvPr>
+          <p:cNvSpPr>
+            <a:spLocks noGrp="1"/>
+          </p:cNvSpPr>
+          <p:nvPr>
+            <p:ph type="dt" sz="half" idx="10"/>
+          </p:nvPr>
+        </p:nvSpPr>
+        <p:spPr/>
+        <p:txBody>
+          <a:bodyPr/>
+          <a:lstStyle/>
+          <a:p>
+            <a:r>
+              <a:rPr lang="en-US"/>
+              <a:t>Vincenzo Gulisano</a:t>
+            </a:r>
           </a:p>
         </p:txBody>
       </p:sp>
@@ -42392,6 +43317,34 @@
           </a:p>
         </p:txBody>
       </p:sp>
+      <p:sp>
+        <p:nvSpPr>
+          <p:cNvPr id="5" name="Date Placeholder 4">
+            <a:extLst>
+              <a:ext uri="{FF2B5EF4-FFF2-40B4-BE49-F238E27FC236}">
+                <a16:creationId xmlns:a16="http://schemas.microsoft.com/office/drawing/2014/main" id="{6BC5B370-1790-62C9-8849-5F400FB524DF}"/>
+              </a:ext>
+            </a:extLst>
+          </p:cNvPr>
+          <p:cNvSpPr>
+            <a:spLocks noGrp="1"/>
+          </p:cNvSpPr>
+          <p:nvPr>
+            <p:ph type="dt" sz="half" idx="10"/>
+          </p:nvPr>
+        </p:nvSpPr>
+        <p:spPr/>
+        <p:txBody>
+          <a:bodyPr/>
+          <a:lstStyle/>
+          <a:p>
+            <a:r>
+              <a:rPr lang="en-US"/>
+              <a:t>Vincenzo Gulisano</a:t>
+            </a:r>
+          </a:p>
+        </p:txBody>
+      </p:sp>
     </p:spTree>
     <p:extLst>
       <p:ext uri="{BB962C8B-B14F-4D97-AF65-F5344CB8AC3E}">
@@ -42849,6 +43802,34 @@
           </a:p>
         </p:txBody>
       </p:sp>
+      <p:sp>
+        <p:nvSpPr>
+          <p:cNvPr id="5" name="Date Placeholder 4">
+            <a:extLst>
+              <a:ext uri="{FF2B5EF4-FFF2-40B4-BE49-F238E27FC236}">
+                <a16:creationId xmlns:a16="http://schemas.microsoft.com/office/drawing/2014/main" id="{220F3303-F6E2-D538-3110-41892067A978}"/>
+              </a:ext>
+            </a:extLst>
+          </p:cNvPr>
+          <p:cNvSpPr>
+            <a:spLocks noGrp="1"/>
+          </p:cNvSpPr>
+          <p:nvPr>
+            <p:ph type="dt" sz="half" idx="10"/>
+          </p:nvPr>
+        </p:nvSpPr>
+        <p:spPr/>
+        <p:txBody>
+          <a:bodyPr/>
+          <a:lstStyle/>
+          <a:p>
+            <a:r>
+              <a:rPr lang="en-US"/>
+              <a:t>Vincenzo Gulisano</a:t>
+            </a:r>
+          </a:p>
+        </p:txBody>
+      </p:sp>
     </p:spTree>
     <p:extLst>
       <p:ext uri="{BB962C8B-B14F-4D97-AF65-F5344CB8AC3E}">
@@ -43071,6 +44052,34 @@
               <a:t>42</a:t>
             </a:fld>
             <a:endParaRPr lang="en-US"/>
+          </a:p>
+        </p:txBody>
+      </p:sp>
+      <p:sp>
+        <p:nvSpPr>
+          <p:cNvPr id="5" name="Date Placeholder 4">
+            <a:extLst>
+              <a:ext uri="{FF2B5EF4-FFF2-40B4-BE49-F238E27FC236}">
+                <a16:creationId xmlns:a16="http://schemas.microsoft.com/office/drawing/2014/main" id="{FDED5A16-2593-A024-3581-4950965F1A9E}"/>
+              </a:ext>
+            </a:extLst>
+          </p:cNvPr>
+          <p:cNvSpPr>
+            <a:spLocks noGrp="1"/>
+          </p:cNvSpPr>
+          <p:nvPr>
+            <p:ph type="dt" sz="half" idx="10"/>
+          </p:nvPr>
+        </p:nvSpPr>
+        <p:spPr/>
+        <p:txBody>
+          <a:bodyPr/>
+          <a:lstStyle/>
+          <a:p>
+            <a:r>
+              <a:rPr lang="en-US"/>
+              <a:t>Vincenzo Gulisano</a:t>
+            </a:r>
           </a:p>
         </p:txBody>
       </p:sp>
@@ -43775,6 +44784,34 @@
           </a:p>
         </p:txBody>
       </p:sp>
+      <p:sp>
+        <p:nvSpPr>
+          <p:cNvPr id="5" name="Date Placeholder 4">
+            <a:extLst>
+              <a:ext uri="{FF2B5EF4-FFF2-40B4-BE49-F238E27FC236}">
+                <a16:creationId xmlns:a16="http://schemas.microsoft.com/office/drawing/2014/main" id="{50E8729E-EC4B-E010-CAB3-BF2D876DD7FE}"/>
+              </a:ext>
+            </a:extLst>
+          </p:cNvPr>
+          <p:cNvSpPr>
+            <a:spLocks noGrp="1"/>
+          </p:cNvSpPr>
+          <p:nvPr>
+            <p:ph type="dt" sz="half" idx="10"/>
+          </p:nvPr>
+        </p:nvSpPr>
+        <p:spPr/>
+        <p:txBody>
+          <a:bodyPr/>
+          <a:lstStyle/>
+          <a:p>
+            <a:r>
+              <a:rPr lang="en-US"/>
+              <a:t>Vincenzo Gulisano</a:t>
+            </a:r>
+          </a:p>
+        </p:txBody>
+      </p:sp>
     </p:spTree>
     <p:extLst>
       <p:ext uri="{BB962C8B-B14F-4D97-AF65-F5344CB8AC3E}">
@@ -44064,6 +45101,34 @@
           </a:p>
         </p:txBody>
       </p:sp>
+      <p:sp>
+        <p:nvSpPr>
+          <p:cNvPr id="3" name="Date Placeholder 2">
+            <a:extLst>
+              <a:ext uri="{FF2B5EF4-FFF2-40B4-BE49-F238E27FC236}">
+                <a16:creationId xmlns:a16="http://schemas.microsoft.com/office/drawing/2014/main" id="{1CF7641F-D3D9-0CC7-938D-A4C3C774749B}"/>
+              </a:ext>
+            </a:extLst>
+          </p:cNvPr>
+          <p:cNvSpPr>
+            <a:spLocks noGrp="1"/>
+          </p:cNvSpPr>
+          <p:nvPr>
+            <p:ph type="dt" sz="half" idx="10"/>
+          </p:nvPr>
+        </p:nvSpPr>
+        <p:spPr/>
+        <p:txBody>
+          <a:bodyPr/>
+          <a:lstStyle/>
+          <a:p>
+            <a:r>
+              <a:rPr lang="en-US"/>
+              <a:t>Vincenzo Gulisano</a:t>
+            </a:r>
+          </a:p>
+        </p:txBody>
+      </p:sp>
     </p:spTree>
     <p:extLst>
       <p:ext uri="{BB962C8B-B14F-4D97-AF65-F5344CB8AC3E}">
@@ -44544,6 +45609,34 @@
               <a:ea typeface="+mj-ea"/>
               <a:cs typeface="+mj-cs"/>
             </a:endParaRPr>
+          </a:p>
+        </p:txBody>
+      </p:sp>
+      <p:sp>
+        <p:nvSpPr>
+          <p:cNvPr id="3" name="Date Placeholder 2">
+            <a:extLst>
+              <a:ext uri="{FF2B5EF4-FFF2-40B4-BE49-F238E27FC236}">
+                <a16:creationId xmlns:a16="http://schemas.microsoft.com/office/drawing/2014/main" id="{5AB89A1B-3719-3D82-7C1D-9154CC396088}"/>
+              </a:ext>
+            </a:extLst>
+          </p:cNvPr>
+          <p:cNvSpPr>
+            <a:spLocks noGrp="1"/>
+          </p:cNvSpPr>
+          <p:nvPr>
+            <p:ph type="dt" sz="half" idx="10"/>
+          </p:nvPr>
+        </p:nvSpPr>
+        <p:spPr/>
+        <p:txBody>
+          <a:bodyPr/>
+          <a:lstStyle/>
+          <a:p>
+            <a:r>
+              <a:rPr lang="en-US"/>
+              <a:t>Vincenzo Gulisano</a:t>
+            </a:r>
           </a:p>
         </p:txBody>
       </p:sp>
@@ -44933,188 +46026,188 @@
           <a:custGeom>
             <a:avLst/>
             <a:gdLst>
-              <a:gd name="connsiteX0" fmla="*/ 0 w 10853928"/>
-              <a:gd name="connsiteY0" fmla="*/ 0 h 18288"/>
-              <a:gd name="connsiteX1" fmla="*/ 461292 w 10853928"/>
-              <a:gd name="connsiteY1" fmla="*/ 0 h 18288"/>
-              <a:gd name="connsiteX2" fmla="*/ 1139662 w 10853928"/>
-              <a:gd name="connsiteY2" fmla="*/ 0 h 18288"/>
-              <a:gd name="connsiteX3" fmla="*/ 1926572 w 10853928"/>
-              <a:gd name="connsiteY3" fmla="*/ 0 h 18288"/>
-              <a:gd name="connsiteX4" fmla="*/ 2279325 w 10853928"/>
-              <a:gd name="connsiteY4" fmla="*/ 0 h 18288"/>
-              <a:gd name="connsiteX5" fmla="*/ 2632078 w 10853928"/>
-              <a:gd name="connsiteY5" fmla="*/ 0 h 18288"/>
-              <a:gd name="connsiteX6" fmla="*/ 3527527 w 10853928"/>
-              <a:gd name="connsiteY6" fmla="*/ 0 h 18288"/>
-              <a:gd name="connsiteX7" fmla="*/ 4205897 w 10853928"/>
-              <a:gd name="connsiteY7" fmla="*/ 0 h 18288"/>
-              <a:gd name="connsiteX8" fmla="*/ 4558650 w 10853928"/>
-              <a:gd name="connsiteY8" fmla="*/ 0 h 18288"/>
-              <a:gd name="connsiteX9" fmla="*/ 5237020 w 10853928"/>
-              <a:gd name="connsiteY9" fmla="*/ 0 h 18288"/>
-              <a:gd name="connsiteX10" fmla="*/ 6132469 w 10853928"/>
-              <a:gd name="connsiteY10" fmla="*/ 0 h 18288"/>
-              <a:gd name="connsiteX11" fmla="*/ 6702301 w 10853928"/>
-              <a:gd name="connsiteY11" fmla="*/ 0 h 18288"/>
-              <a:gd name="connsiteX12" fmla="*/ 7272132 w 10853928"/>
-              <a:gd name="connsiteY12" fmla="*/ 0 h 18288"/>
-              <a:gd name="connsiteX13" fmla="*/ 7950502 w 10853928"/>
-              <a:gd name="connsiteY13" fmla="*/ 0 h 18288"/>
-              <a:gd name="connsiteX14" fmla="*/ 8737412 w 10853928"/>
-              <a:gd name="connsiteY14" fmla="*/ 0 h 18288"/>
-              <a:gd name="connsiteX15" fmla="*/ 9524322 w 10853928"/>
-              <a:gd name="connsiteY15" fmla="*/ 0 h 18288"/>
-              <a:gd name="connsiteX16" fmla="*/ 10853928 w 10853928"/>
-              <a:gd name="connsiteY16" fmla="*/ 0 h 18288"/>
-              <a:gd name="connsiteX17" fmla="*/ 10853928 w 10853928"/>
-              <a:gd name="connsiteY17" fmla="*/ 18288 h 18288"/>
-              <a:gd name="connsiteX18" fmla="*/ 10392636 w 10853928"/>
-              <a:gd name="connsiteY18" fmla="*/ 18288 h 18288"/>
-              <a:gd name="connsiteX19" fmla="*/ 9497187 w 10853928"/>
-              <a:gd name="connsiteY19" fmla="*/ 18288 h 18288"/>
-              <a:gd name="connsiteX20" fmla="*/ 8818817 w 10853928"/>
-              <a:gd name="connsiteY20" fmla="*/ 18288 h 18288"/>
-              <a:gd name="connsiteX21" fmla="*/ 8466064 w 10853928"/>
-              <a:gd name="connsiteY21" fmla="*/ 18288 h 18288"/>
-              <a:gd name="connsiteX22" fmla="*/ 7787693 w 10853928"/>
-              <a:gd name="connsiteY22" fmla="*/ 18288 h 18288"/>
-              <a:gd name="connsiteX23" fmla="*/ 7217862 w 10853928"/>
-              <a:gd name="connsiteY23" fmla="*/ 18288 h 18288"/>
-              <a:gd name="connsiteX24" fmla="*/ 6648031 w 10853928"/>
-              <a:gd name="connsiteY24" fmla="*/ 18288 h 18288"/>
-              <a:gd name="connsiteX25" fmla="*/ 6078200 w 10853928"/>
-              <a:gd name="connsiteY25" fmla="*/ 18288 h 18288"/>
-              <a:gd name="connsiteX26" fmla="*/ 5508368 w 10853928"/>
-              <a:gd name="connsiteY26" fmla="*/ 18288 h 18288"/>
-              <a:gd name="connsiteX27" fmla="*/ 4721459 w 10853928"/>
-              <a:gd name="connsiteY27" fmla="*/ 18288 h 18288"/>
-              <a:gd name="connsiteX28" fmla="*/ 4043088 w 10853928"/>
-              <a:gd name="connsiteY28" fmla="*/ 18288 h 18288"/>
-              <a:gd name="connsiteX29" fmla="*/ 3690336 w 10853928"/>
-              <a:gd name="connsiteY29" fmla="*/ 18288 h 18288"/>
-              <a:gd name="connsiteX30" fmla="*/ 3120504 w 10853928"/>
-              <a:gd name="connsiteY30" fmla="*/ 18288 h 18288"/>
-              <a:gd name="connsiteX31" fmla="*/ 2333595 w 10853928"/>
-              <a:gd name="connsiteY31" fmla="*/ 18288 h 18288"/>
-              <a:gd name="connsiteX32" fmla="*/ 1872303 w 10853928"/>
-              <a:gd name="connsiteY32" fmla="*/ 18288 h 18288"/>
-              <a:gd name="connsiteX33" fmla="*/ 976854 w 10853928"/>
-              <a:gd name="connsiteY33" fmla="*/ 18288 h 18288"/>
-              <a:gd name="connsiteX34" fmla="*/ 0 w 10853928"/>
-              <a:gd name="connsiteY34" fmla="*/ 18288 h 18288"/>
-              <a:gd name="connsiteX35" fmla="*/ 0 w 10853928"/>
-              <a:gd name="connsiteY35" fmla="*/ 0 h 18288"/>
+              <a:gd name="csX0" fmla="*/ 0 w 10853928"/>
+              <a:gd name="csY0" fmla="*/ 0 h 18288"/>
+              <a:gd name="csX1" fmla="*/ 461292 w 10853928"/>
+              <a:gd name="csY1" fmla="*/ 0 h 18288"/>
+              <a:gd name="csX2" fmla="*/ 1139662 w 10853928"/>
+              <a:gd name="csY2" fmla="*/ 0 h 18288"/>
+              <a:gd name="csX3" fmla="*/ 1926572 w 10853928"/>
+              <a:gd name="csY3" fmla="*/ 0 h 18288"/>
+              <a:gd name="csX4" fmla="*/ 2279325 w 10853928"/>
+              <a:gd name="csY4" fmla="*/ 0 h 18288"/>
+              <a:gd name="csX5" fmla="*/ 2632078 w 10853928"/>
+              <a:gd name="csY5" fmla="*/ 0 h 18288"/>
+              <a:gd name="csX6" fmla="*/ 3527527 w 10853928"/>
+              <a:gd name="csY6" fmla="*/ 0 h 18288"/>
+              <a:gd name="csX7" fmla="*/ 4205897 w 10853928"/>
+              <a:gd name="csY7" fmla="*/ 0 h 18288"/>
+              <a:gd name="csX8" fmla="*/ 4558650 w 10853928"/>
+              <a:gd name="csY8" fmla="*/ 0 h 18288"/>
+              <a:gd name="csX9" fmla="*/ 5237020 w 10853928"/>
+              <a:gd name="csY9" fmla="*/ 0 h 18288"/>
+              <a:gd name="csX10" fmla="*/ 6132469 w 10853928"/>
+              <a:gd name="csY10" fmla="*/ 0 h 18288"/>
+              <a:gd name="csX11" fmla="*/ 6702301 w 10853928"/>
+              <a:gd name="csY11" fmla="*/ 0 h 18288"/>
+              <a:gd name="csX12" fmla="*/ 7272132 w 10853928"/>
+              <a:gd name="csY12" fmla="*/ 0 h 18288"/>
+              <a:gd name="csX13" fmla="*/ 7950502 w 10853928"/>
+              <a:gd name="csY13" fmla="*/ 0 h 18288"/>
+              <a:gd name="csX14" fmla="*/ 8737412 w 10853928"/>
+              <a:gd name="csY14" fmla="*/ 0 h 18288"/>
+              <a:gd name="csX15" fmla="*/ 9524322 w 10853928"/>
+              <a:gd name="csY15" fmla="*/ 0 h 18288"/>
+              <a:gd name="csX16" fmla="*/ 10853928 w 10853928"/>
+              <a:gd name="csY16" fmla="*/ 0 h 18288"/>
+              <a:gd name="csX17" fmla="*/ 10853928 w 10853928"/>
+              <a:gd name="csY17" fmla="*/ 18288 h 18288"/>
+              <a:gd name="csX18" fmla="*/ 10392636 w 10853928"/>
+              <a:gd name="csY18" fmla="*/ 18288 h 18288"/>
+              <a:gd name="csX19" fmla="*/ 9497187 w 10853928"/>
+              <a:gd name="csY19" fmla="*/ 18288 h 18288"/>
+              <a:gd name="csX20" fmla="*/ 8818817 w 10853928"/>
+              <a:gd name="csY20" fmla="*/ 18288 h 18288"/>
+              <a:gd name="csX21" fmla="*/ 8466064 w 10853928"/>
+              <a:gd name="csY21" fmla="*/ 18288 h 18288"/>
+              <a:gd name="csX22" fmla="*/ 7787693 w 10853928"/>
+              <a:gd name="csY22" fmla="*/ 18288 h 18288"/>
+              <a:gd name="csX23" fmla="*/ 7217862 w 10853928"/>
+              <a:gd name="csY23" fmla="*/ 18288 h 18288"/>
+              <a:gd name="csX24" fmla="*/ 6648031 w 10853928"/>
+              <a:gd name="csY24" fmla="*/ 18288 h 18288"/>
+              <a:gd name="csX25" fmla="*/ 6078200 w 10853928"/>
+              <a:gd name="csY25" fmla="*/ 18288 h 18288"/>
+              <a:gd name="csX26" fmla="*/ 5508368 w 10853928"/>
+              <a:gd name="csY26" fmla="*/ 18288 h 18288"/>
+              <a:gd name="csX27" fmla="*/ 4721459 w 10853928"/>
+              <a:gd name="csY27" fmla="*/ 18288 h 18288"/>
+              <a:gd name="csX28" fmla="*/ 4043088 w 10853928"/>
+              <a:gd name="csY28" fmla="*/ 18288 h 18288"/>
+              <a:gd name="csX29" fmla="*/ 3690336 w 10853928"/>
+              <a:gd name="csY29" fmla="*/ 18288 h 18288"/>
+              <a:gd name="csX30" fmla="*/ 3120504 w 10853928"/>
+              <a:gd name="csY30" fmla="*/ 18288 h 18288"/>
+              <a:gd name="csX31" fmla="*/ 2333595 w 10853928"/>
+              <a:gd name="csY31" fmla="*/ 18288 h 18288"/>
+              <a:gd name="csX32" fmla="*/ 1872303 w 10853928"/>
+              <a:gd name="csY32" fmla="*/ 18288 h 18288"/>
+              <a:gd name="csX33" fmla="*/ 976854 w 10853928"/>
+              <a:gd name="csY33" fmla="*/ 18288 h 18288"/>
+              <a:gd name="csX34" fmla="*/ 0 w 10853928"/>
+              <a:gd name="csY34" fmla="*/ 18288 h 18288"/>
+              <a:gd name="csX35" fmla="*/ 0 w 10853928"/>
+              <a:gd name="csY35" fmla="*/ 0 h 18288"/>
             </a:gdLst>
             <a:ahLst/>
             <a:cxnLst>
               <a:cxn ang="0">
-                <a:pos x="connsiteX0" y="connsiteY0"/>
+                <a:pos x="csX0" y="csY0"/>
               </a:cxn>
               <a:cxn ang="0">
-                <a:pos x="connsiteX1" y="connsiteY1"/>
+                <a:pos x="csX1" y="csY1"/>
               </a:cxn>
               <a:cxn ang="0">
-                <a:pos x="connsiteX2" y="connsiteY2"/>
+                <a:pos x="csX2" y="csY2"/>
               </a:cxn>
               <a:cxn ang="0">
-                <a:pos x="connsiteX3" y="connsiteY3"/>
+                <a:pos x="csX3" y="csY3"/>
               </a:cxn>
               <a:cxn ang="0">
-                <a:pos x="connsiteX4" y="connsiteY4"/>
+                <a:pos x="csX4" y="csY4"/>
               </a:cxn>
               <a:cxn ang="0">
-                <a:pos x="connsiteX5" y="connsiteY5"/>
+                <a:pos x="csX5" y="csY5"/>
               </a:cxn>
               <a:cxn ang="0">
-                <a:pos x="connsiteX6" y="connsiteY6"/>
+                <a:pos x="csX6" y="csY6"/>
               </a:cxn>
               <a:cxn ang="0">
-                <a:pos x="connsiteX7" y="connsiteY7"/>
+                <a:pos x="csX7" y="csY7"/>
               </a:cxn>
               <a:cxn ang="0">
-                <a:pos x="connsiteX8" y="connsiteY8"/>
+                <a:pos x="csX8" y="csY8"/>
               </a:cxn>
               <a:cxn ang="0">
-                <a:pos x="connsiteX9" y="connsiteY9"/>
+                <a:pos x="csX9" y="csY9"/>
               </a:cxn>
               <a:cxn ang="0">
-                <a:pos x="connsiteX10" y="connsiteY10"/>
+                <a:pos x="csX10" y="csY10"/>
               </a:cxn>
               <a:cxn ang="0">
-                <a:pos x="connsiteX11" y="connsiteY11"/>
+                <a:pos x="csX11" y="csY11"/>
               </a:cxn>
               <a:cxn ang="0">
-                <a:pos x="connsiteX12" y="connsiteY12"/>
+                <a:pos x="csX12" y="csY12"/>
               </a:cxn>
               <a:cxn ang="0">
-                <a:pos x="connsiteX13" y="connsiteY13"/>
+                <a:pos x="csX13" y="csY13"/>
               </a:cxn>
               <a:cxn ang="0">
-                <a:pos x="connsiteX14" y="connsiteY14"/>
+                <a:pos x="csX14" y="csY14"/>
               </a:cxn>
               <a:cxn ang="0">
-                <a:pos x="connsiteX15" y="connsiteY15"/>
+                <a:pos x="csX15" y="csY15"/>
               </a:cxn>
               <a:cxn ang="0">
-                <a:pos x="connsiteX16" y="connsiteY16"/>
+                <a:pos x="csX16" y="csY16"/>
               </a:cxn>
               <a:cxn ang="0">
-                <a:pos x="connsiteX17" y="connsiteY17"/>
+                <a:pos x="csX17" y="csY17"/>
               </a:cxn>
               <a:cxn ang="0">
-                <a:pos x="connsiteX18" y="connsiteY18"/>
+                <a:pos x="csX18" y="csY18"/>
               </a:cxn>
               <a:cxn ang="0">
-                <a:pos x="connsiteX19" y="connsiteY19"/>
+                <a:pos x="csX19" y="csY19"/>
               </a:cxn>
               <a:cxn ang="0">
-                <a:pos x="connsiteX20" y="connsiteY20"/>
+                <a:pos x="csX20" y="csY20"/>
               </a:cxn>
               <a:cxn ang="0">
-                <a:pos x="connsiteX21" y="connsiteY21"/>
+                <a:pos x="csX21" y="csY21"/>
               </a:cxn>
               <a:cxn ang="0">
-                <a:pos x="connsiteX22" y="connsiteY22"/>
+                <a:pos x="csX22" y="csY22"/>
               </a:cxn>
               <a:cxn ang="0">
-                <a:pos x="connsiteX23" y="connsiteY23"/>
+                <a:pos x="csX23" y="csY23"/>
               </a:cxn>
               <a:cxn ang="0">
-                <a:pos x="connsiteX24" y="connsiteY24"/>
+                <a:pos x="csX24" y="csY24"/>
               </a:cxn>
               <a:cxn ang="0">
-                <a:pos x="connsiteX25" y="connsiteY25"/>
+                <a:pos x="csX25" y="csY25"/>
               </a:cxn>
               <a:cxn ang="0">
-                <a:pos x="connsiteX26" y="connsiteY26"/>
+                <a:pos x="csX26" y="csY26"/>
               </a:cxn>
               <a:cxn ang="0">
-                <a:pos x="connsiteX27" y="connsiteY27"/>
+                <a:pos x="csX27" y="csY27"/>
               </a:cxn>
               <a:cxn ang="0">
-                <a:pos x="connsiteX28" y="connsiteY28"/>
+                <a:pos x="csX28" y="csY28"/>
               </a:cxn>
               <a:cxn ang="0">
-                <a:pos x="connsiteX29" y="connsiteY29"/>
+                <a:pos x="csX29" y="csY29"/>
               </a:cxn>
               <a:cxn ang="0">
-                <a:pos x="connsiteX30" y="connsiteY30"/>
+                <a:pos x="csX30" y="csY30"/>
               </a:cxn>
               <a:cxn ang="0">
-                <a:pos x="connsiteX31" y="connsiteY31"/>
+                <a:pos x="csX31" y="csY31"/>
               </a:cxn>
               <a:cxn ang="0">
-                <a:pos x="connsiteX32" y="connsiteY32"/>
+                <a:pos x="csX32" y="csY32"/>
               </a:cxn>
               <a:cxn ang="0">
-                <a:pos x="connsiteX33" y="connsiteY33"/>
+                <a:pos x="csX33" y="csY33"/>
               </a:cxn>
               <a:cxn ang="0">
-                <a:pos x="connsiteX34" y="connsiteY34"/>
+                <a:pos x="csX34" y="csY34"/>
               </a:cxn>
               <a:cxn ang="0">
-                <a:pos x="connsiteX35" y="connsiteY35"/>
+                <a:pos x="csX35" y="csY35"/>
               </a:cxn>
             </a:cxnLst>
             <a:rect l="l" t="t" r="r" b="b"/>
@@ -45795,6 +46888,34 @@
               <a:t>5</a:t>
             </a:fld>
             <a:endParaRPr lang="en-US"/>
+          </a:p>
+        </p:txBody>
+      </p:sp>
+      <p:sp>
+        <p:nvSpPr>
+          <p:cNvPr id="3" name="Date Placeholder 2">
+            <a:extLst>
+              <a:ext uri="{FF2B5EF4-FFF2-40B4-BE49-F238E27FC236}">
+                <a16:creationId xmlns:a16="http://schemas.microsoft.com/office/drawing/2014/main" id="{A632FEA2-FE6C-7CDB-C8FA-6CD084B67921}"/>
+              </a:ext>
+            </a:extLst>
+          </p:cNvPr>
+          <p:cNvSpPr>
+            <a:spLocks noGrp="1"/>
+          </p:cNvSpPr>
+          <p:nvPr>
+            <p:ph type="dt" sz="half" idx="10"/>
+          </p:nvPr>
+        </p:nvSpPr>
+        <p:spPr/>
+        <p:txBody>
+          <a:bodyPr/>
+          <a:lstStyle/>
+          <a:p>
+            <a:r>
+              <a:rPr lang="en-US"/>
+              <a:t>Vincenzo Gulisano</a:t>
+            </a:r>
           </a:p>
         </p:txBody>
       </p:sp>
@@ -46582,6 +47703,34 @@
               <a:t>6</a:t>
             </a:fld>
             <a:endParaRPr lang="en-US"/>
+          </a:p>
+        </p:txBody>
+      </p:sp>
+      <p:sp>
+        <p:nvSpPr>
+          <p:cNvPr id="4" name="Date Placeholder 3">
+            <a:extLst>
+              <a:ext uri="{FF2B5EF4-FFF2-40B4-BE49-F238E27FC236}">
+                <a16:creationId xmlns:a16="http://schemas.microsoft.com/office/drawing/2014/main" id="{1BE142D0-C9B6-D693-88D5-623B3C06AE2B}"/>
+              </a:ext>
+            </a:extLst>
+          </p:cNvPr>
+          <p:cNvSpPr>
+            <a:spLocks noGrp="1"/>
+          </p:cNvSpPr>
+          <p:nvPr>
+            <p:ph type="dt" sz="half" idx="10"/>
+          </p:nvPr>
+        </p:nvSpPr>
+        <p:spPr/>
+        <p:txBody>
+          <a:bodyPr/>
+          <a:lstStyle/>
+          <a:p>
+            <a:r>
+              <a:rPr lang="en-US"/>
+              <a:t>Vincenzo Gulisano</a:t>
+            </a:r>
           </a:p>
         </p:txBody>
       </p:sp>
@@ -48180,6 +49329,34 @@
           </a:p>
         </p:txBody>
       </p:sp>
+      <p:sp>
+        <p:nvSpPr>
+          <p:cNvPr id="4" name="Date Placeholder 3">
+            <a:extLst>
+              <a:ext uri="{FF2B5EF4-FFF2-40B4-BE49-F238E27FC236}">
+                <a16:creationId xmlns:a16="http://schemas.microsoft.com/office/drawing/2014/main" id="{9A849DE9-C85F-1FC8-CFD3-9BD7ED47120D}"/>
+              </a:ext>
+            </a:extLst>
+          </p:cNvPr>
+          <p:cNvSpPr>
+            <a:spLocks noGrp="1"/>
+          </p:cNvSpPr>
+          <p:nvPr>
+            <p:ph type="dt" sz="half" idx="10"/>
+          </p:nvPr>
+        </p:nvSpPr>
+        <p:spPr/>
+        <p:txBody>
+          <a:bodyPr/>
+          <a:lstStyle/>
+          <a:p>
+            <a:r>
+              <a:rPr lang="en-US"/>
+              <a:t>Vincenzo Gulisano</a:t>
+            </a:r>
+          </a:p>
+        </p:txBody>
+      </p:sp>
     </p:spTree>
     <p:extLst>
       <p:ext uri="{BB962C8B-B14F-4D97-AF65-F5344CB8AC3E}">
@@ -48775,6 +49952,34 @@
           </a:p>
         </p:txBody>
       </p:sp>
+      <p:sp>
+        <p:nvSpPr>
+          <p:cNvPr id="5" name="Date Placeholder 4">
+            <a:extLst>
+              <a:ext uri="{FF2B5EF4-FFF2-40B4-BE49-F238E27FC236}">
+                <a16:creationId xmlns:a16="http://schemas.microsoft.com/office/drawing/2014/main" id="{83F0F789-2BC9-D73B-D703-CEF455FBD7C3}"/>
+              </a:ext>
+            </a:extLst>
+          </p:cNvPr>
+          <p:cNvSpPr>
+            <a:spLocks noGrp="1"/>
+          </p:cNvSpPr>
+          <p:nvPr>
+            <p:ph type="dt" sz="half" idx="10"/>
+          </p:nvPr>
+        </p:nvSpPr>
+        <p:spPr/>
+        <p:txBody>
+          <a:bodyPr/>
+          <a:lstStyle/>
+          <a:p>
+            <a:r>
+              <a:rPr lang="en-US"/>
+              <a:t>Vincenzo Gulisano</a:t>
+            </a:r>
+          </a:p>
+        </p:txBody>
+      </p:sp>
     </p:spTree>
     <p:extLst>
       <p:ext uri="{BB962C8B-B14F-4D97-AF65-F5344CB8AC3E}">
@@ -49887,6 +51092,34 @@
                 </a:solidFill>
               </a:rPr>
               <a:t>.  Variety of formulations, e.g., FCFS; or bounded #bypasses, …</a:t>
+            </a:r>
+          </a:p>
+        </p:txBody>
+      </p:sp>
+      <p:sp>
+        <p:nvSpPr>
+          <p:cNvPr id="2" name="Date Placeholder 1">
+            <a:extLst>
+              <a:ext uri="{FF2B5EF4-FFF2-40B4-BE49-F238E27FC236}">
+                <a16:creationId xmlns:a16="http://schemas.microsoft.com/office/drawing/2014/main" id="{40986FEB-3C84-EF97-2B0A-7DF363F74840}"/>
+              </a:ext>
+            </a:extLst>
+          </p:cNvPr>
+          <p:cNvSpPr>
+            <a:spLocks noGrp="1"/>
+          </p:cNvSpPr>
+          <p:nvPr>
+            <p:ph type="dt" sz="half" idx="10"/>
+          </p:nvPr>
+        </p:nvSpPr>
+        <p:spPr/>
+        <p:txBody>
+          <a:bodyPr/>
+          <a:lstStyle/>
+          <a:p>
+            <a:r>
+              <a:rPr lang="en-US"/>
+              <a:t>Vincenzo Gulisano</a:t>
             </a:r>
           </a:p>
         </p:txBody>

</xml_diff>

<commit_message>
fixed reading instructions in synchronization slides
</commit_message>
<xml_diff>
--- a/slides/synchronization_part_1.pptx
+++ b/slides/synchronization_part_1.pptx
@@ -558,7 +558,7 @@
           <a:p>
             <a:fld id="{B9670FC7-431C-3445-825C-360F18AD9FB0}" type="datetimeFigureOut">
               <a:rPr lang="en-US" smtClean="0"/>
-              <a:t>7/14/26</a:t>
+              <a:t>7/15/26</a:t>
             </a:fld>
             <a:endParaRPr lang="en-US"/>
           </a:p>
@@ -21540,30 +21540,7 @@
           <a:p>
             <a:r>
               <a:rPr lang="en-US" dirty="0"/>
-              <a:t>4</a:t>
-            </a:r>
-            <a:r>
-              <a:rPr lang="en-US" baseline="30000" dirty="0"/>
-              <a:t>th</a:t>
-            </a:r>
-            <a:r>
-              <a:rPr lang="en-US" dirty="0"/>
-              <a:t> edition</a:t>
-            </a:r>
-          </a:p>
-          <a:p>
-            <a:pPr lvl="1"/>
-            <a:r>
-              <a:rPr lang="en-US" dirty="0"/>
-              <a:t>Chapter 2.3.1-2.3.6, </a:t>
-            </a:r>
-            <a:r>
-              <a:rPr lang="en-GB" dirty="0"/>
-              <a:t>2.5.1-</a:t>
-            </a:r>
-            <a:r>
-              <a:rPr lang="en-US" dirty="0"/>
-              <a:t>2.5.2, </a:t>
+              <a:t>Chapter 2.4.1-2.4.6, </a:t>
             </a:r>
             <a:r>
               <a:rPr lang="en-GB" dirty="0"/>
@@ -21575,81 +21552,13 @@
             </a:r>
           </a:p>
           <a:p>
-            <a:pPr lvl="1"/>
             <a:r>
               <a:rPr lang="en-US" dirty="0"/>
-              <a:t>Quicker reading, for awareness, of sections 2.3.7-2.3.10, </a:t>
-            </a:r>
-            <a:r>
-              <a:rPr lang="en-GB" dirty="0"/>
+              <a:t>Quicker reading, for awareness, of sections 2.3.7-2.3.9, 2.3.11, </a:t>
+            </a:r>
+            <a:r>
+              <a:rPr lang="en-GB"/>
               <a:t>6.3</a:t>
-            </a:r>
-          </a:p>
-          <a:p>
-            <a:r>
-              <a:rPr lang="en-US" dirty="0"/>
-              <a:t>5</a:t>
-            </a:r>
-            <a:r>
-              <a:rPr lang="en-US" baseline="30000" dirty="0"/>
-              <a:t>th</a:t>
-            </a:r>
-            <a:r>
-              <a:rPr lang="en-US" dirty="0"/>
-              <a:t> edition</a:t>
-            </a:r>
-          </a:p>
-          <a:p>
-            <a:pPr lvl="1"/>
-            <a:r>
-              <a:rPr lang="en-US" dirty="0"/>
-              <a:t>Chapter 2.4.1-2.4.6, </a:t>
-            </a:r>
-            <a:r>
-              <a:rPr lang="en-GB" dirty="0"/>
-              <a:t>6.1-6.2, 6.5-6.6, 6.7.3-6.7.4</a:t>
-            </a:r>
-            <a:r>
-              <a:rPr lang="en-US" dirty="0"/>
-              <a:t>; </a:t>
-            </a:r>
-          </a:p>
-          <a:p>
-            <a:pPr lvl="1"/>
-            <a:r>
-              <a:rPr lang="en-US" dirty="0"/>
-              <a:t>Quicker reading, for awareness, of </a:t>
-            </a:r>
-            <a:r>
-              <a:rPr lang="en-US"/>
-              <a:t>sections 2.3.7-2.3.9, 2.3.11, </a:t>
-            </a:r>
-            <a:r>
-              <a:rPr lang="en-GB" dirty="0"/>
-              <a:t>6.3</a:t>
-            </a:r>
-            <a:br>
-              <a:rPr lang="en-US" dirty="0"/>
-            </a:br>
-            <a:br>
-              <a:rPr lang="en-US" dirty="0"/>
-            </a:br>
-            <a:br>
-              <a:rPr lang="en-US" dirty="0"/>
-            </a:br>
-            <a:endParaRPr lang="en-US" dirty="0"/>
-          </a:p>
-          <a:p>
-            <a:pPr marL="457200" lvl="1" indent="0">
-              <a:buNone/>
-            </a:pPr>
-            <a:r>
-              <a:rPr lang="en-US" dirty="0"/>
-              <a:t>(</a:t>
-            </a:r>
-            <a:r>
-              <a:rPr lang="en-GB" dirty="0"/>
-              <a:t>facultative reading: sections 6.1-6.7, 6.9, 7.1-7.5, 7.6-7.8 from OS Concepts by Silberschatz et-al).</a:t>
             </a:r>
             <a:endParaRPr lang="en-US" dirty="0"/>
           </a:p>

</xml_diff>